<commit_message>
Paper 2 slides: drop page refs, whole-paper summary, one methodology slide, references slide
Co-Authored-By: Claude Opus 5.5 <noreply@anthropic.com>
Claude-Session: https://claude.ai/code/session_01U1DJd2gSQyyin3TdCJkPvd
</commit_message>
<xml_diff>
--- a/Vorl_2/slides/lecture2-team-paper2.pptx
+++ b/Vorl_2/slides/lecture2-team-paper2.pptx
@@ -25,13 +25,12 @@
     <p:sldId id="323" r:id="rId81"/>
     <p:sldId id="269" r:id="rId19"/>
     <p:sldId id="270" r:id="rId20"/>
+    <p:sldId id="271" r:id="rId21"/>
     <p:sldId id="324" r:id="rId82"/>
-    <p:sldId id="271" r:id="rId21"/>
     <p:sldId id="325" r:id="rId83"/>
     <p:sldId id="326" r:id="rId84"/>
     <p:sldId id="327" r:id="rId85"/>
     <p:sldId id="328" r:id="rId86"/>
-    <p:sldId id="329" r:id="rId87"/>
     <p:sldId id="272" r:id="rId22"/>
     <p:sldId id="273" r:id="rId23"/>
     <p:sldId id="274" r:id="rId24"/>
@@ -46,6 +45,7 @@
     <p:sldId id="283" r:id="rId33"/>
     <p:sldId id="284" r:id="rId34"/>
     <p:sldId id="285" r:id="rId35"/>
+    <p:sldId id="329" r:id="rId87"/>
     <p:sldId id="286" r:id="rId36"/>
     <p:sldId id="287" r:id="rId37"/>
     <p:sldId id="288" r:id="rId38"/>
@@ -2064,7 +2064,7 @@
           <a:lstStyle/>
           <a:p>
             <a:r>
-              <a:t>Abstract, p. 1; intro pp. 2-3. Issues stem from four areas: communication, social system (reward), time (bitrot), technical aspects (ease of use) (p. 3). Authors argue AECs are well positioned to fix many issues (p. 3). Earlier work (Collberg) showed artifacts often lack documentation and have unstated dependencies; the controversy around it shows there are no clear community standards (p. 2).</a:t>
+              <a:t>Abstract p. 1; intro pp. 2-3. Issues stem from four areas: communication, social system (reward), time (bitrot), technical aspects (p. 3). Collberg et al.'s earlier work and its controversy show there are no clear community standards (p. 2). Secondary analysis (§5) and recommendations (§6) are presented by a teammate.</a:t>
             </a:r>
           </a:p>
         </p:txBody>
@@ -2516,7 +2516,7 @@
           <a:lstStyle/>
           <a:p>
             <a:r>
-              <a:t>Fig. 1, p. 7; contributions p. 3. RQs p. 6. Secondary analysis (DoI, §5) and recommendations (§6) are covered by a teammate. Replication package on Zenodo: survey materials, quantitative results, publication data, mining scripts (p. 3).</a:t>
+              <a:t>Fig. 1 p. 7; §3.1 p. 7; §3.2 pp. 7-9; design p. 10. 899 artifacts in 1434 papers; availability checked 29 Jan - 6 Feb 2019. 744 authors emailed, 153 of 698 delivered completed (22%); 91% academic; creators 137, users 129, reviewers 32. Coding: descriptive then axial, 3 domain experts + 1 methodologist. Secondary analysis and recommendations covered by a teammate.</a:t>
             </a:r>
           </a:p>
         </p:txBody>
@@ -11986,7 +11986,7 @@
           <a:lstStyle/>
           <a:p>
             <a:r>
-              <a:t>Publication survey: 899 artifacts in 1434 papers; availability checked 29 Jan - 6 Feb 2019. Author survey: 744 emailed, 153 of 698 delivered completed (22%); 91% academic; creators 137, users 129, reviewers 32 (Table 2). Table 1 grouping: RQ1 Q5,Q10,Q12 · RQ2.1 Q3,Q4,Q6-Q9 · RQ2.2 Q11 · RQ2.3 Q13-Q15 · all Q16 · demographics Q1,Q2.</a:t>
+              <a:t>Themes from thematic analysis: they show which challenges exist, not how common each is (p. 9). Overall: issues stem from communication, social system, time and technical aspects.</a:t>
             </a:r>
           </a:p>
         </p:txBody>
@@ -12214,7 +12214,7 @@
           <a:lstStyle/>
           <a:p>
             <a:r>
-              <a:t>Themes from thematic analysis: they show which challenges exist, not how common each is (p. 9). Overall: issues stem from communication, social system, time and technical aspects.</a:t>
+              <a:t>C1: opportunity cost highest when submitting to an AEC (P1, P23, p. 13). P87: no time, scared the analysis is wrong, wanted to save it for the next paper. C2 Table 5: no build instructions 79, unavailable dependency 69, missing dependency 66, modified source 60, run-time error 55, reimplemented 28. C3: users sympathetic; P20: only well-funded groups maintain artifacts well (p. 19).</a:t>
             </a:r>
           </a:p>
         </p:txBody>
@@ -12284,7 +12284,7 @@
           <a:lstStyle/>
           <a:p>
             <a:r>
-              <a:t>C1: opportunity cost highest when submitting to an AEC (P1, P23, p. 13). P87: no time, scared the analysis is wrong, wanted to save it for the next paper. C2 Table 5: no build instructions 79, unavailable dependency 69, missing dependency 66, modified source 60, run-time error 55, reimplemented 28. C3: users sympathetic; P20: only well-funded groups maintain artifacts well (p. 19).</a:t>
+              <a:t>C4 Table 5: no usage instructions 103 (most common), no build instructions 79 (third). P25: AECs asking for replicable scripts are likely to replicate the authors’ mistakes. P52: easy to reproduce, hard to know where to add case studies. C6: P6 deep dives take days, "if the AEC doesn’t do it, will anybody ever?"; P11 evaluate as part of paper; P124/P146 mandatory; P143 rubber stamp.</a:t>
             </a:r>
           </a:p>
         </p:txBody>
@@ -12354,7 +12354,7 @@
           <a:lstStyle/>
           <a:p>
             <a:r>
-              <a:t>C4 Table 5: no usage instructions 103 (most common), no build instructions 79 (third). P25: AECs asking for replicable scripts are likely to replicate the authors’ mistakes. P52: easy to reproduce, hard to know where to add case studies. C6: P6 deep dives take days, "if the AEC doesn’t do it, will anybody ever?"; P11 evaluate as part of paper; P124/P146 mandatory; P143 rubber stamp.</a:t>
+              <a:t>C7: ~14% of artifact links dead in early 2019: 26.47% for 2014 papers, 5.43% for 2018 (Fig. 3). Research: Zenodo free, DOI, 50-200 GB, GitHub release integration; ICSE now requires an archive for Available. C8: research: Anonymous GitHub hides names but links expire. C9: ACM "Complete" allows proxies for proprietary data.</a:t>
             </a:r>
           </a:p>
         </p:txBody>
@@ -12380,76 +12380,6 @@
 </file>
 
 <file path=ppt/notesSlides/notesSlide73.xml><?xml version="1.0" encoding="utf-8"?>
-<p:notes xmlns:a="http://schemas.openxmlformats.org/drawingml/2006/main" xmlns:p="http://schemas.openxmlformats.org/presentationml/2006/main" xmlns:r="http://schemas.openxmlformats.org/officeDocument/2006/relationships">
-  <p:cSld>
-    <p:spTree>
-      <p:nvGrpSpPr>
-        <p:cNvPr id="1" name=""/>
-        <p:cNvGrpSpPr/>
-        <p:nvPr/>
-      </p:nvGrpSpPr>
-      <p:grpSpPr>
-        <a:xfrm>
-          <a:off x="0" y="0"/>
-          <a:ext cx="0" cy="0"/>
-          <a:chOff x="0" y="0"/>
-          <a:chExt cx="0" cy="0"/>
-        </a:xfrm>
-      </p:grpSpPr>
-      <p:sp>
-        <p:nvSpPr>
-          <p:cNvPr id="2" name="Slide Image Placeholder 1"/>
-          <p:cNvSpPr>
-            <a:spLocks noGrp="1"/>
-          </p:cNvSpPr>
-          <p:nvPr>
-            <p:ph type="sldImg" idx="3"/>
-          </p:nvPr>
-        </p:nvSpPr>
-        <p:spPr/>
-      </p:sp>
-      <p:sp>
-        <p:nvSpPr>
-          <p:cNvPr id="3" name="Notes Placeholder 2"/>
-          <p:cNvSpPr>
-            <a:spLocks noGrp="1"/>
-          </p:cNvSpPr>
-          <p:nvPr>
-            <p:ph type="body" idx="1"/>
-          </p:nvPr>
-        </p:nvSpPr>
-        <p:spPr/>
-        <p:txBody>
-          <a:bodyPr/>
-          <a:lstStyle/>
-          <a:p>
-            <a:r>
-              <a:t>C7: ~14% of artifact links dead in early 2019: 26.47% for 2014 papers, 5.43% for 2018 (Fig. 3). Research: Zenodo free, DOI, 50-200 GB, GitHub release integration; ICSE now requires an archive for Available. C8: research: Anonymous GitHub hides names but links expire. C9: ACM "Complete" allows proxies for proprietary data.</a:t>
-            </a:r>
-          </a:p>
-        </p:txBody>
-      </p:sp>
-      <p:sp>
-        <p:nvSpPr>
-          <p:cNvPr id="4" name="Slide Number Placeholder 3"/>
-          <p:cNvSpPr>
-            <a:spLocks noGrp="1"/>
-          </p:cNvSpPr>
-          <p:nvPr>
-            <p:ph type="sldNum" idx="12"/>
-          </p:nvPr>
-        </p:nvSpPr>
-        <p:spPr/>
-      </p:sp>
-    </p:spTree>
-  </p:cSld>
-  <p:clrMapOvr>
-    <a:masterClrMapping/>
-  </p:clrMapOvr>
-</p:notes>
-</file>
-
-<file path=ppt/notesSlides/notesSlide74.xml><?xml version="1.0" encoding="utf-8"?>
 <p:notes xmlns:a="http://schemas.openxmlformats.org/drawingml/2006/main" xmlns:p="http://schemas.openxmlformats.org/presentationml/2006/main" xmlns:r="http://schemas.openxmlformats.org/officeDocument/2006/relationships">
   <p:cSld>
     <p:spTree>
@@ -14749,13 +14679,13 @@
               </a:spcAft>
             </a:pPr>
             <a:r>
-              <a:rPr sz="2200" b="1" i="0">
+              <a:rPr sz="2400" b="1" i="0">
                 <a:solidFill>
                   <a:srgbClr val="00883A"/>
                 </a:solidFill>
                 <a:latin typeface="Arial"/>
               </a:rPr>
-              <a:t>Week 1: why are working artifacts so rare?</a:t>
+              <a:t>Why is making good artifacts hard?</a:t>
             </a:r>
           </a:p>
           <a:p>
@@ -14765,13 +14695,13 @@
               </a:spcAft>
             </a:pPr>
             <a:r>
-              <a:rPr sz="2200" b="1" i="0">
+              <a:rPr sz="2400" b="1" i="0">
                 <a:solidFill>
                   <a:srgbClr val="00883A"/>
                 </a:solidFill>
                 <a:latin typeface="Arial"/>
               </a:rPr>
-              <a:t>This paper: why is making good artifacts so hard?</a:t>
+              <a:t>Potential solutions to this?</a:t>
             </a:r>
           </a:p>
         </p:txBody>
@@ -14784,8 +14714,8 @@
         </p:nvSpPr>
         <p:spPr>
           <a:xfrm>
-            <a:off x="3968496" y="1600200"/>
-            <a:ext cx="7589520" cy="4572000"/>
+            <a:off x="3968496" y="1463040"/>
+            <a:ext cx="7589520" cy="4754880"/>
           </a:xfrm>
           <a:prstGeom prst="rect">
             <a:avLst/>
@@ -14804,7 +14734,7 @@
               </a:spcAft>
             </a:pPr>
             <a:r>
-              <a:rPr sz="2000" b="1" i="0">
+              <a:rPr sz="1900" b="1" i="0">
                 <a:solidFill>
                   <a:srgbClr val="1A1A1A"/>
                 </a:solidFill>
@@ -14813,13 +14743,13 @@
               <a:t>Problem: </a:t>
             </a:r>
             <a:r>
-              <a:rPr sz="2000" b="0" i="0">
+              <a:rPr sz="1900" b="0" i="0">
                 <a:solidFill>
                   <a:srgbClr val="1A1A1A"/>
                 </a:solidFill>
                 <a:latin typeface="Arial"/>
               </a:rPr>
-              <a:t>artifacts (tools, benchmarks, data) should support claims and future research, but in practice fall short</a:t>
+              <a:t>artifacts (tools, benchmarks, data) should back claims and enable future research, but in practice fall short</a:t>
             </a:r>
           </a:p>
           <a:p>
@@ -14829,22 +14759,22 @@
               </a:spcAft>
             </a:pPr>
             <a:r>
-              <a:rPr sz="2000" b="1" i="0">
+              <a:rPr sz="1900" b="1" i="0">
                 <a:solidFill>
                   <a:srgbClr val="1A1A1A"/>
                 </a:solidFill>
                 <a:latin typeface="Arial"/>
               </a:rPr>
-              <a:t>Goal: </a:t>
-            </a:r>
-            <a:r>
-              <a:rPr sz="2000" b="0" i="0">
+              <a:t>Approach: </a:t>
+            </a:r>
+            <a:r>
+              <a:rPr sz="1900" b="0" i="0">
                 <a:solidFill>
                   <a:srgbClr val="1A1A1A"/>
                 </a:solidFill>
                 <a:latin typeface="Arial"/>
               </a:rPr>
-              <a:t>understand the challenges of creating, sharing, using and reviewing artifacts</a:t>
+              <a:t>mixed methods: survey of artifacts in top SE publications + online survey of SE researchers; creator, user and reviewer views</a:t>
             </a:r>
           </a:p>
           <a:p>
@@ -14854,22 +14784,22 @@
               </a:spcAft>
             </a:pPr>
             <a:r>
-              <a:rPr sz="2000" b="1" i="0">
+              <a:rPr sz="1900" b="1" i="0">
                 <a:solidFill>
                   <a:srgbClr val="1A1A1A"/>
                 </a:solidFill>
                 <a:latin typeface="Arial"/>
               </a:rPr>
-              <a:t>Approach: </a:t>
-            </a:r>
-            <a:r>
-              <a:rPr sz="2000" b="0" i="0">
+              <a:t>Findings: </a:t>
+            </a:r>
+            <a:r>
+              <a:rPr sz="1900" b="0" i="0">
                 <a:solidFill>
                   <a:srgbClr val="1A1A1A"/>
                 </a:solidFill>
                 <a:latin typeface="Arial"/>
               </a:rPr>
-              <a:t>mixed methods: survey of SE publications + online survey of SE researchers, seen from three angles: creators, users, reviewers</a:t>
+              <a:t>sharing is valued and widespread, but 12 challenges stand in the way; key issues are mismatched expectations and too little reward for creators and reviewers</a:t>
             </a:r>
           </a:p>
           <a:p>
@@ -14879,22 +14809,22 @@
               </a:spcAft>
             </a:pPr>
             <a:r>
-              <a:rPr sz="2000" b="1" i="0">
+              <a:rPr sz="1900" b="1" i="0">
                 <a:solidFill>
                   <a:srgbClr val="1A1A1A"/>
                 </a:solidFill>
                 <a:latin typeface="Arial"/>
               </a:rPr>
-              <a:t>Finding: </a:t>
-            </a:r>
-            <a:r>
-              <a:rPr sz="2000" b="0" i="0">
+              <a:t>Analysis: </a:t>
+            </a:r>
+            <a:r>
+              <a:rPr sz="1900" b="0" i="0">
                 <a:solidFill>
                   <a:srgbClr val="1A1A1A"/>
                 </a:solidFill>
                 <a:latin typeface="Arial"/>
               </a:rPr>
-              <a:t>mismatched expectations between the groups and too little reward for creators and reviewers</a:t>
+              <a:t>Diffusion of Innovations links the challenges via communication, time and the social system</a:t>
             </a:r>
           </a:p>
           <a:p>
@@ -14904,22 +14834,22 @@
               </a:spcAft>
             </a:pPr>
             <a:r>
-              <a:rPr sz="2000" b="1" i="0">
+              <a:rPr sz="1900" b="1" i="0">
                 <a:solidFill>
                   <a:srgbClr val="1A1A1A"/>
                 </a:solidFill>
                 <a:latin typeface="Arial"/>
               </a:rPr>
-              <a:t>Output: </a:t>
-            </a:r>
-            <a:r>
-              <a:rPr sz="2000" b="0" i="0">
+              <a:t>Solutions: </a:t>
+            </a:r>
+            <a:r>
+              <a:rPr sz="1900" b="0" i="0">
                 <a:solidFill>
                   <a:srgbClr val="1A1A1A"/>
                 </a:solidFill>
                 <a:latin typeface="Arial"/>
               </a:rPr>
-              <a:t>recommendations to improve artifact quality (later section)</a:t>
+              <a:t>8 recommendations for creators, reviewers, organisers and community leaders; AECs are well placed to raise artifact quality</a:t>
             </a:r>
           </a:p>
         </p:txBody>
@@ -15191,7 +15121,7 @@
                 </a:solidFill>
                 <a:latin typeface="Arial"/>
               </a:rPr>
-              <a:t>any external material linked from a paper: tools, code, data, replication packages, companion sites, survey instruments, proofs (pp. 3-4)</a:t>
+              <a:t>any external material linked from a paper: tools, code, data, replication packages, companion sites, survey instruments, proofs</a:t>
             </a:r>
           </a:p>
         </p:txBody>
@@ -15315,7 +15245,7 @@
                 </a:solidFill>
                 <a:latin typeface="Arial"/>
               </a:rPr>
-              <a:t>digital object created for the study or generated by it (p. 4)</a:t>
+              <a:t>digital object created for the study or generated by it</a:t>
             </a:r>
           </a:p>
         </p:txBody>
@@ -15439,7 +15369,7 @@
                 </a:solidFill>
                 <a:latin typeface="Arial"/>
               </a:rPr>
-              <a:t>Artifact Evaluation Committee: reviews artifacts of accepted papers; opt-in, after acceptance, cannot reject a paper (p. 4)</a:t>
+              <a:t>Artifact Evaluation Committee: reviews artifacts of accepted papers; opt-in, after acceptance, cannot reject a paper</a:t>
             </a:r>
           </a:p>
         </p:txBody>
@@ -15563,7 +15493,7 @@
                 </a:solidFill>
                 <a:latin typeface="Arial"/>
               </a:rPr>
-              <a:t>documented · consistent (supports main results) · complete (proprietary parts may be replaced by proxies) · exercisable (pp. 4-5)</a:t>
+              <a:t>documented · consistent (supports main results) · complete (proprietary parts may be replaced by proxies) · exercisable</a:t>
             </a:r>
           </a:p>
         </p:txBody>
@@ -16046,7 +15976,7 @@
         </p:nvSpPr>
         <p:spPr>
           <a:xfrm>
-            <a:off x="640080" y="1280160"/>
+            <a:off x="640080" y="1234440"/>
             <a:ext cx="10908792" cy="548640"/>
           </a:xfrm>
           <a:prstGeom prst="rect">
@@ -16081,7 +16011,7 @@
                 </a:solidFill>
                 <a:latin typeface="Arial"/>
               </a:rPr>
-              <a:t>two studies run at the same time, analysed separately, then merged (p. 10)</a:t>
+              <a:t>two studies at the same time, analysed separately, then merged</a:t>
             </a:r>
           </a:p>
         </p:txBody>
@@ -16094,8 +16024,8 @@
         </p:nvSpPr>
         <p:spPr>
           <a:xfrm>
-            <a:off x="640080" y="2103120"/>
-            <a:ext cx="5212080" cy="2377440"/>
+            <a:off x="640080" y="1965960"/>
+            <a:ext cx="5212080" cy="3657600"/>
           </a:xfrm>
           <a:prstGeom prst="roundRect">
             <a:avLst>
@@ -16140,8 +16070,8 @@
         </p:nvSpPr>
         <p:spPr>
           <a:xfrm>
-            <a:off x="822959" y="2194560"/>
-            <a:ext cx="4846320" cy="2194560"/>
+            <a:off x="822959" y="2057400"/>
+            <a:ext cx="4846320" cy="3474720"/>
           </a:xfrm>
           <a:prstGeom prst="rect">
             <a:avLst/>
@@ -16156,7 +16086,7 @@
           <a:p>
             <a:pPr>
               <a:spcAft>
-                <a:spcPts val="600"/>
+                <a:spcPts val="1000"/>
               </a:spcAft>
             </a:pPr>
             <a:r>
@@ -16172,7 +16102,7 @@
           <a:p>
             <a:pPr>
               <a:spcAft>
-                <a:spcPts val="600"/>
+                <a:spcPts val="1000"/>
               </a:spcAft>
             </a:pPr>
             <a:r>
@@ -16182,13 +16112,13 @@
                 </a:solidFill>
                 <a:latin typeface="Arial"/>
               </a:rPr>
-              <a:t>all technical-track papers</a:t>
+              <a:t>• all technical-track papers, ICSE · FSE · ASE · EMSE, 2014-2018</a:t>
             </a:r>
           </a:p>
           <a:p>
             <a:pPr>
               <a:spcAft>
-                <a:spcPts val="600"/>
+                <a:spcPts val="1000"/>
               </a:spcAft>
             </a:pPr>
             <a:r>
@@ -16198,13 +16128,13 @@
                 </a:solidFill>
                 <a:latin typeface="Arial"/>
               </a:rPr>
-              <a:t>ICSE · FSE · ASE · EMSE</a:t>
+              <a:t>• links found in the papers, checked by hand</a:t>
             </a:r>
           </a:p>
           <a:p>
             <a:pPr>
               <a:spcAft>
-                <a:spcPts val="600"/>
+                <a:spcPts val="1000"/>
               </a:spcAft>
             </a:pPr>
             <a:r>
@@ -16214,13 +16144,13 @@
                 </a:solidFill>
                 <a:latin typeface="Arial"/>
               </a:rPr>
-              <a:t>2014-2018</a:t>
+              <a:t>• artifact = any linked material; available = link still works</a:t>
             </a:r>
           </a:p>
           <a:p>
             <a:pPr>
               <a:spcAft>
-                <a:spcPts val="600"/>
+                <a:spcPts val="1000"/>
               </a:spcAft>
             </a:pPr>
             <a:r>
@@ -16230,7 +16160,7 @@
                 </a:solidFill>
                 <a:latin typeface="Arial"/>
               </a:rPr>
-              <a:t>→ prevalence and availability</a:t>
+              <a:t>• AEC chairs asked for submission and acceptance data</a:t>
             </a:r>
           </a:p>
         </p:txBody>
@@ -16243,8 +16173,8 @@
         </p:nvSpPr>
         <p:spPr>
           <a:xfrm>
-            <a:off x="6336792" y="2103120"/>
-            <a:ext cx="5212080" cy="2377440"/>
+            <a:off x="6336792" y="1965960"/>
+            <a:ext cx="5212080" cy="3657600"/>
           </a:xfrm>
           <a:prstGeom prst="roundRect">
             <a:avLst>
@@ -16289,8 +16219,8 @@
         </p:nvSpPr>
         <p:spPr>
           <a:xfrm>
-            <a:off x="6519672" y="2194560"/>
-            <a:ext cx="4846320" cy="2194560"/>
+            <a:off x="6519672" y="2057400"/>
+            <a:ext cx="4846320" cy="3474720"/>
           </a:xfrm>
           <a:prstGeom prst="rect">
             <a:avLst/>
@@ -16305,7 +16235,7 @@
           <a:p>
             <a:pPr>
               <a:spcAft>
-                <a:spcPts val="600"/>
+                <a:spcPts val="1000"/>
               </a:spcAft>
             </a:pPr>
             <a:r>
@@ -16321,7 +16251,7 @@
           <a:p>
             <a:pPr>
               <a:spcAft>
-                <a:spcPts val="600"/>
+                <a:spcPts val="1000"/>
               </a:spcAft>
             </a:pPr>
             <a:r>
@@ -16331,13 +16261,13 @@
                 </a:solidFill>
                 <a:latin typeface="Arial"/>
               </a:rPr>
-              <a:t>online questionnaire</a:t>
+              <a:t>• online questionnaire for authors of 2018 papers</a:t>
             </a:r>
           </a:p>
           <a:p>
             <a:pPr>
               <a:spcAft>
-                <a:spcPts val="600"/>
+                <a:spcPts val="1000"/>
               </a:spcAft>
             </a:pPr>
             <a:r>
@@ -16347,13 +16277,13 @@
                 </a:solidFill>
                 <a:latin typeface="Arial"/>
               </a:rPr>
-              <a:t>authors of 2018 papers</a:t>
+              <a:t>• branching by role: creator, user, reviewer</a:t>
             </a:r>
           </a:p>
           <a:p>
             <a:pPr>
               <a:spcAft>
-                <a:spcPts val="600"/>
+                <a:spcPts val="1000"/>
               </a:spcAft>
             </a:pPr>
             <a:r>
@@ -16363,13 +16293,13 @@
                 </a:solidFill>
                 <a:latin typeface="Arial"/>
               </a:rPr>
-              <a:t>creators · users · reviewers</a:t>
+              <a:t>• open answers coded into themes (range, not frequency)</a:t>
             </a:r>
           </a:p>
           <a:p>
             <a:pPr>
               <a:spcAft>
-                <a:spcPts val="600"/>
+                <a:spcPts val="1000"/>
               </a:spcAft>
             </a:pPr>
             <a:r>
@@ -16379,110 +16309,21 @@
                 </a:solidFill>
                 <a:latin typeface="Arial"/>
               </a:rPr>
-              <a:t>→ perceived value and challenges</a:t>
-            </a:r>
-          </a:p>
-        </p:txBody>
-      </p:sp>
-      <p:sp>
-        <p:nvSpPr>
-          <p:cNvPr id="162" name="Down Arrow 161"/>
-          <p:cNvSpPr/>
-          <p:nvPr/>
-        </p:nvSpPr>
-        <p:spPr>
-          <a:xfrm>
-            <a:off x="5824728" y="4572000"/>
-            <a:ext cx="548640" cy="457200"/>
-          </a:xfrm>
-          <a:prstGeom prst="downArrow">
-            <a:avLst/>
-          </a:prstGeom>
-          <a:solidFill>
-            <a:srgbClr val="00883A"/>
-          </a:solidFill>
-          <a:ln>
-            <a:noFill/>
-          </a:ln>
-        </p:spPr>
-        <p:style>
-          <a:lnRef idx="1">
-            <a:schemeClr val="accent1"/>
-          </a:lnRef>
-          <a:fillRef idx="3">
-            <a:schemeClr val="accent1"/>
-          </a:fillRef>
-          <a:effectRef idx="2">
-            <a:schemeClr val="accent1"/>
-          </a:effectRef>
-          <a:fontRef idx="minor">
-            <a:schemeClr val="lt1"/>
-          </a:fontRef>
-        </p:style>
-        <p:txBody>
-          <a:bodyPr rtlCol="0" anchor="ctr"/>
-          <a:lstStyle/>
-          <a:p>
-            <a:pPr algn="ctr"/>
-          </a:p>
-        </p:txBody>
-      </p:sp>
-      <p:sp>
-        <p:nvSpPr>
-          <p:cNvPr id="163" name="Rounded Rectangle 162"/>
-          <p:cNvSpPr/>
-          <p:nvPr/>
-        </p:nvSpPr>
-        <p:spPr>
-          <a:xfrm>
-            <a:off x="2286000" y="5120640"/>
-            <a:ext cx="7616952" cy="914400"/>
-          </a:xfrm>
-          <a:prstGeom prst="roundRect">
-            <a:avLst>
-              <a:gd name="adj" fmla="val 8000"/>
-            </a:avLst>
-          </a:prstGeom>
-          <a:solidFill>
-            <a:srgbClr val="F1F3F2"/>
-          </a:solidFill>
-          <a:ln>
-            <a:noFill/>
-          </a:ln>
-          <a:effectLst/>
-        </p:spPr>
-        <p:style>
-          <a:lnRef idx="1">
-            <a:schemeClr val="accent1"/>
-          </a:lnRef>
-          <a:fillRef idx="3">
-            <a:schemeClr val="accent1"/>
-          </a:fillRef>
-          <a:effectRef idx="2">
-            <a:schemeClr val="accent1"/>
-          </a:effectRef>
-          <a:fontRef idx="minor">
-            <a:schemeClr val="lt1"/>
-          </a:fontRef>
-        </p:style>
-        <p:txBody>
-          <a:bodyPr rtlCol="0" anchor="ctr"/>
-          <a:lstStyle/>
-          <a:p>
-            <a:pPr algn="ctr"/>
-          </a:p>
-        </p:txBody>
-      </p:sp>
-      <p:sp>
-        <p:nvSpPr>
-          <p:cNvPr id="164" name="TextBox 163"/>
+              <a:t>• questions mapped to RQ1 (value) and RQ2 (challenges)</a:t>
+            </a:r>
+          </a:p>
+        </p:txBody>
+      </p:sp>
+      <p:sp>
+        <p:nvSpPr>
+          <p:cNvPr id="162" name="TextBox 161"/>
           <p:cNvSpPr txBox="1"/>
           <p:nvPr/>
         </p:nvSpPr>
         <p:spPr>
           <a:xfrm>
-            <a:off x="2468880" y="5166360"/>
-            <a:ext cx="7251192" cy="822960"/>
+            <a:off x="640080" y="5760720"/>
+            <a:ext cx="10908792" cy="457200"/>
           </a:xfrm>
           <a:prstGeom prst="rect">
             <a:avLst/>
@@ -16490,33 +16331,33 @@
           <a:noFill/>
         </p:spPr>
         <p:txBody>
-          <a:bodyPr wrap="square" anchor="ctr">
+          <a:bodyPr wrap="square">
             <a:spAutoFit/>
           </a:bodyPr>
           <a:lstStyle/>
           <a:p>
-            <a:pPr algn="ctr">
+            <a:pPr>
               <a:spcAft>
                 <a:spcPts val="600"/>
               </a:spcAft>
             </a:pPr>
             <a:r>
-              <a:rPr sz="1900" b="1" i="0">
+              <a:rPr sz="1800" b="1" i="0">
                 <a:solidFill>
                   <a:srgbClr val="00883A"/>
                 </a:solidFill>
                 <a:latin typeface="Arial"/>
               </a:rPr>
-              <a:t>Integrated results (§4): </a:t>
-            </a:r>
-            <a:r>
-              <a:rPr sz="1900" b="0" i="0">
+              <a:t>→ </a:t>
+            </a:r>
+            <a:r>
+              <a:rPr sz="1800" b="0" i="0">
                 <a:solidFill>
                   <a:srgbClr val="1A1A1A"/>
                 </a:solidFill>
                 <a:latin typeface="Arial"/>
               </a:rPr>
-              <a:t>RQ1 value · RQ2 challenges</a:t>
+              <a:t>merged into the results: RQ1 value · RQ2 challenges</a:t>
             </a:r>
           </a:p>
         </p:txBody>
@@ -16797,7 +16638,7 @@
                 </a:solidFill>
                 <a:latin typeface="Arial"/>
               </a:rPr>
-              <a:t>artifacts are seen as inherently valuable; sharing is an established and growing norm (most papers now link one, p. 11)</a:t>
+              <a:t>artifacts are seen as inherently valuable; sharing is an established and growing norm (most papers now link one)</a:t>
             </a:r>
           </a:p>
           <a:p>
@@ -16852,7 +16693,7 @@
                 </a:solidFill>
                 <a:latin typeface="Arial"/>
               </a:rPr>
-              <a:t>Why authors share (Table 3, p. 12)</a:t>
+              <a:t>Why authors share</a:t>
             </a:r>
           </a:p>
         </p:txBody>
@@ -17528,7 +17369,7 @@
                 </a:solidFill>
                 <a:latin typeface="Arial"/>
               </a:rPr>
-              <a:t>data and scripts shared; qualitative answers kept confidential (p. 10)</a:t>
+              <a:t>data and scripts shared; qualitative answers kept confidential</a:t>
             </a:r>
           </a:p>
         </p:txBody>
@@ -17652,7 +17493,7 @@
                 </a:solidFill>
                 <a:latin typeface="Arial"/>
               </a:rPr>
-              <a:t>artifact = any link; unlinked artifacts missed; authors not contacted (p. 10)</a:t>
+              <a:t>artifact = any link; unlinked artifacts missed; authors not contacted</a:t>
             </a:r>
           </a:p>
         </p:txBody>
@@ -17776,7 +17617,7 @@
                 </a:solidFill>
                 <a:latin typeface="Arial"/>
               </a:rPr>
-              <a:t>survey bias from respondents and researchers; triangulation, documented coding (pp. 10-11)</a:t>
+              <a:t>survey bias from respondents and researchers; triangulation, documented coding</a:t>
             </a:r>
           </a:p>
         </p:txBody>
@@ -17900,7 +17741,7 @@
                 </a:solidFill>
                 <a:latin typeface="Arial"/>
               </a:rPr>
-              <a:t>link still works; content and quality not checked (p. 11)</a:t>
+              <a:t>link still works; content and quality not checked</a:t>
             </a:r>
           </a:p>
         </p:txBody>
@@ -18024,7 +17865,7 @@
                 </a:solidFill>
                 <a:latin typeface="Arial"/>
               </a:rPr>
-              <a:t>results describe only the SE research community (p. 11)</a:t>
+              <a:t>results describe only the SE research community</a:t>
             </a:r>
           </a:p>
         </p:txBody>
@@ -42970,7 +42811,7 @@
                 </a:solidFill>
                 <a:latin typeface="Arial"/>
               </a:rPr>
-              <a:t>ACM badges (policy v1.1, 2020; lecture slide 9)</a:t>
+              <a:t>ACM badges [1, 2]</a:t>
             </a:r>
           </a:p>
         </p:txBody>
@@ -43444,7 +43285,7 @@
                 </a:solidFill>
                 <a:latin typeface="Arial"/>
               </a:rPr>
-              <a:t>Paper (p. 4): "Available, Evaluated, Results Validated". ACM only defines the badges; each conference’s AEC sets its own concrete rules.</a:t>
+              <a:t>The paper names "Available, Evaluated, Results Validated"; Results Validated is now split in two. ACM only defines the badges; each conference’s AEC sets its own concrete rules [1, 3].</a:t>
             </a:r>
           </a:p>
         </p:txBody>
@@ -43624,7 +43465,7 @@
                 </a:solidFill>
                 <a:latin typeface="Arial"/>
               </a:rPr>
-              <a:t>Diffusion of Innovations (DoI): how new ideas and practices spread (p. 5)</a:t>
+              <a:t>Diffusion of Innovations (DoI): how new ideas and practices spread</a:t>
             </a:r>
           </a:p>
         </p:txBody>
@@ -44170,7 +44011,7 @@
                 </a:solidFill>
                 <a:latin typeface="Arial"/>
               </a:rPr>
-              <a:t>iterative, evidence-based way of moving research into practice (from medicine): practices identified, trialled, observed, improved (p. 6). Used to shape the recommendations.</a:t>
+              <a:t>iterative, evidence-based way of moving research into practice (from medicine): practices identified, trialled, observed, improved. Used to shape the recommendations.</a:t>
             </a:r>
           </a:p>
         </p:txBody>
@@ -44242,7 +44083,7 @@
                 <a:cs typeface="Arial"/>
                 <a:sym typeface="Arial"/>
               </a:rPr>
-              <a:t>Methodology</a:t>
+              <a:t>Results</a:t>
             </a:r>
             <a:endParaRPr b="0" i="0" sz="4000" u="none" cap="none" strike="noStrike">
               <a:solidFill>
@@ -44318,14 +44159,53 @@
       </p:sp>
       <p:sp>
         <p:nvSpPr>
-          <p:cNvPr id="134" name="Rounded Rectangle 133"/>
+          <p:cNvPr id="134" name="TextBox 133"/>
+          <p:cNvSpPr txBox="1"/>
+          <p:nvPr/>
+        </p:nvSpPr>
+        <p:spPr>
+          <a:xfrm>
+            <a:off x="640080" y="1097280"/>
+            <a:ext cx="9144000" cy="365760"/>
+          </a:xfrm>
+          <a:prstGeom prst="rect">
+            <a:avLst/>
+          </a:prstGeom>
+          <a:noFill/>
+        </p:spPr>
+        <p:txBody>
+          <a:bodyPr wrap="square">
+            <a:spAutoFit/>
+          </a:bodyPr>
+          <a:lstStyle/>
+          <a:p>
+            <a:pPr>
+              <a:spcAft>
+                <a:spcPts val="600"/>
+              </a:spcAft>
+            </a:pPr>
+            <a:r>
+              <a:rPr sz="1600" b="1" i="0">
+                <a:solidFill>
+                  <a:srgbClr val="5F6368"/>
+                </a:solidFill>
+                <a:latin typeface="Arial"/>
+              </a:rPr>
+              <a:t>RQ2 · Challenges of creating, sharing, using and reviewing</a:t>
+            </a:r>
+          </a:p>
+        </p:txBody>
+      </p:sp>
+      <p:sp>
+        <p:nvSpPr>
+          <p:cNvPr id="135" name="Rounded Rectangle 134"/>
           <p:cNvSpPr/>
           <p:nvPr/>
         </p:nvSpPr>
         <p:spPr>
           <a:xfrm>
-            <a:off x="640080" y="1463040"/>
-            <a:ext cx="5212080" cy="4572000"/>
+            <a:off x="640080" y="1600200"/>
+            <a:ext cx="2587752" cy="1188720"/>
           </a:xfrm>
           <a:prstGeom prst="roundRect">
             <a:avLst>
@@ -44364,14 +44244,14 @@
       </p:sp>
       <p:sp>
         <p:nvSpPr>
-          <p:cNvPr id="135" name="TextBox 134"/>
+          <p:cNvPr id="136" name="TextBox 135"/>
           <p:cNvSpPr txBox="1"/>
           <p:nvPr/>
         </p:nvSpPr>
         <p:spPr>
           <a:xfrm>
-            <a:off x="822959" y="1554480"/>
-            <a:ext cx="4846320" cy="4389120"/>
+            <a:off x="749808" y="1673352"/>
+            <a:ext cx="2377440" cy="1051560"/>
           </a:xfrm>
           <a:prstGeom prst="rect">
             <a:avLst/>
@@ -44386,95 +44266,56 @@
           <a:p>
             <a:pPr>
               <a:spcAft>
-                <a:spcPts val="1200"/>
-              </a:spcAft>
-            </a:pPr>
-            <a:r>
-              <a:rPr sz="2100" b="1" i="0">
+                <a:spcPts val="400"/>
+              </a:spcAft>
+            </a:pPr>
+            <a:r>
+              <a:rPr sz="1800" b="1" i="0">
                 <a:solidFill>
                   <a:srgbClr val="00883A"/>
                 </a:solidFill>
                 <a:latin typeface="Arial"/>
               </a:rPr>
-              <a:t>§3.1 Publication survey (p. 7)</a:t>
+              <a:t>C1 </a:t>
+            </a:r>
+            <a:r>
+              <a:rPr sz="1700" b="0" i="0">
+                <a:solidFill>
+                  <a:srgbClr val="1A1A1A"/>
+                </a:solidFill>
+                <a:latin typeface="Arial"/>
+              </a:rPr>
+              <a:t>Not worth it</a:t>
             </a:r>
           </a:p>
           <a:p>
             <a:pPr>
               <a:spcAft>
-                <a:spcPts val="1200"/>
-              </a:spcAft>
-            </a:pPr>
-            <a:r>
-              <a:rPr sz="1800" b="0" i="0">
-                <a:solidFill>
-                  <a:srgbClr val="1A1A1A"/>
-                </a:solidFill>
-                <a:latin typeface="Arial"/>
-              </a:rPr>
-              <a:t>• URLs extracted from paper PDFs, then checked by hand</a:t>
-            </a:r>
-          </a:p>
-          <a:p>
-            <a:pPr>
-              <a:spcAft>
-                <a:spcPts val="1200"/>
-              </a:spcAft>
-            </a:pPr>
-            <a:r>
-              <a:rPr sz="1800" b="0" i="0">
-                <a:solidFill>
-                  <a:srgbClr val="1A1A1A"/>
-                </a:solidFill>
-                <a:latin typeface="Arial"/>
-              </a:rPr>
-              <a:t>• artifact = any linked material</a:t>
-            </a:r>
-          </a:p>
-          <a:p>
-            <a:pPr>
-              <a:spcAft>
-                <a:spcPts val="1200"/>
-              </a:spcAft>
-            </a:pPr>
-            <a:r>
-              <a:rPr sz="1800" b="0" i="0">
-                <a:solidFill>
-                  <a:srgbClr val="1A1A1A"/>
-                </a:solidFill>
-                <a:latin typeface="Arial"/>
-              </a:rPr>
-              <a:t>• available = URL reachable at one check (early 2019)</a:t>
-            </a:r>
-          </a:p>
-          <a:p>
-            <a:pPr>
-              <a:spcAft>
-                <a:spcPts val="1200"/>
-              </a:spcAft>
-            </a:pPr>
-            <a:r>
-              <a:rPr sz="1800" b="0" i="0">
-                <a:solidFill>
-                  <a:srgbClr val="1A1A1A"/>
-                </a:solidFill>
-                <a:latin typeface="Arial"/>
-              </a:rPr>
-              <a:t>• FSE AEC chairs asked for submission and acceptance data</a:t>
-            </a:r>
-          </a:p>
-        </p:txBody>
-      </p:sp>
-      <p:sp>
-        <p:nvSpPr>
-          <p:cNvPr id="136" name="Rounded Rectangle 135"/>
+                <a:spcPts val="400"/>
+              </a:spcAft>
+            </a:pPr>
+            <a:r>
+              <a:rPr sz="1800" b="1" i="0">
+                <a:solidFill>
+                  <a:srgbClr val="00883A"/>
+                </a:solidFill>
+                <a:latin typeface="Arial"/>
+              </a:rPr>
+              <a:t>■ </a:t>
+            </a:r>
+          </a:p>
+        </p:txBody>
+      </p:sp>
+      <p:sp>
+        <p:nvSpPr>
+          <p:cNvPr id="137" name="Rounded Rectangle 136"/>
           <p:cNvSpPr/>
           <p:nvPr/>
         </p:nvSpPr>
         <p:spPr>
           <a:xfrm>
-            <a:off x="6336792" y="1463040"/>
-            <a:ext cx="5212080" cy="4572000"/>
+            <a:off x="3410711" y="1600200"/>
+            <a:ext cx="2587752" cy="1188720"/>
           </a:xfrm>
           <a:prstGeom prst="roundRect">
             <a:avLst>
@@ -44513,14 +44354,14 @@
       </p:sp>
       <p:sp>
         <p:nvSpPr>
-          <p:cNvPr id="137" name="TextBox 136"/>
+          <p:cNvPr id="138" name="TextBox 137"/>
           <p:cNvSpPr txBox="1"/>
           <p:nvPr/>
         </p:nvSpPr>
         <p:spPr>
           <a:xfrm>
-            <a:off x="6519672" y="1554480"/>
-            <a:ext cx="4846320" cy="4389120"/>
+            <a:off x="3520439" y="1673352"/>
+            <a:ext cx="2377440" cy="1051560"/>
           </a:xfrm>
           <a:prstGeom prst="rect">
             <a:avLst/>
@@ -44535,81 +44376,1307 @@
           <a:p>
             <a:pPr>
               <a:spcAft>
-                <a:spcPts val="1200"/>
-              </a:spcAft>
-            </a:pPr>
-            <a:r>
-              <a:rPr sz="2100" b="1" i="0">
+                <a:spcPts val="400"/>
+              </a:spcAft>
+            </a:pPr>
+            <a:r>
+              <a:rPr sz="1800" b="1" i="0">
                 <a:solidFill>
                   <a:srgbClr val="00883A"/>
                 </a:solidFill>
                 <a:latin typeface="Arial"/>
               </a:rPr>
-              <a:t>§3.2 Author survey (pp. 7-9)</a:t>
+              <a:t>C2 </a:t>
+            </a:r>
+            <a:r>
+              <a:rPr sz="1700" b="0" i="0">
+                <a:solidFill>
+                  <a:srgbClr val="1A1A1A"/>
+                </a:solidFill>
+                <a:latin typeface="Arial"/>
+              </a:rPr>
+              <a:t>Portability</a:t>
             </a:r>
           </a:p>
           <a:p>
             <a:pPr>
               <a:spcAft>
-                <a:spcPts val="1200"/>
-              </a:spcAft>
-            </a:pPr>
-            <a:r>
-              <a:rPr sz="1800" b="0" i="0">
+                <a:spcPts val="400"/>
+              </a:spcAft>
+            </a:pPr>
+            <a:r>
+              <a:rPr sz="1800" b="1" i="0">
+                <a:solidFill>
+                  <a:srgbClr val="00883A"/>
+                </a:solidFill>
+                <a:latin typeface="Arial"/>
+              </a:rPr>
+              <a:t>■ </a:t>
+            </a:r>
+            <a:r>
+              <a:rPr sz="1800" b="1" i="0">
+                <a:solidFill>
+                  <a:srgbClr val="5F6368"/>
+                </a:solidFill>
+                <a:latin typeface="Arial"/>
+              </a:rPr>
+              <a:t>▲ </a:t>
+            </a:r>
+            <a:r>
+              <a:rPr sz="1800" b="1" i="0">
                 <a:solidFill>
                   <a:srgbClr val="1A1A1A"/>
                 </a:solidFill>
                 <a:latin typeface="Arial"/>
               </a:rPr>
-              <a:t>• closed + open questions; branching shows role-specific parts</a:t>
-            </a:r>
-          </a:p>
+              <a:t>★ </a:t>
+            </a:r>
+          </a:p>
+        </p:txBody>
+      </p:sp>
+      <p:sp>
+        <p:nvSpPr>
+          <p:cNvPr id="139" name="Rounded Rectangle 138"/>
+          <p:cNvSpPr/>
+          <p:nvPr/>
+        </p:nvSpPr>
+        <p:spPr>
+          <a:xfrm>
+            <a:off x="6181344" y="1600200"/>
+            <a:ext cx="2587752" cy="1188720"/>
+          </a:xfrm>
+          <a:prstGeom prst="roundRect">
+            <a:avLst>
+              <a:gd name="adj" fmla="val 8000"/>
+            </a:avLst>
+          </a:prstGeom>
+          <a:solidFill>
+            <a:srgbClr val="F1F3F2"/>
+          </a:solidFill>
+          <a:ln>
+            <a:noFill/>
+          </a:ln>
+          <a:effectLst/>
+        </p:spPr>
+        <p:style>
+          <a:lnRef idx="1">
+            <a:schemeClr val="accent1"/>
+          </a:lnRef>
+          <a:fillRef idx="3">
+            <a:schemeClr val="accent1"/>
+          </a:fillRef>
+          <a:effectRef idx="2">
+            <a:schemeClr val="accent1"/>
+          </a:effectRef>
+          <a:fontRef idx="minor">
+            <a:schemeClr val="lt1"/>
+          </a:fontRef>
+        </p:style>
+        <p:txBody>
+          <a:bodyPr rtlCol="0" anchor="ctr"/>
+          <a:lstStyle/>
+          <a:p>
+            <a:pPr algn="ctr"/>
+          </a:p>
+        </p:txBody>
+      </p:sp>
+      <p:sp>
+        <p:nvSpPr>
+          <p:cNvPr id="140" name="TextBox 139"/>
+          <p:cNvSpPr txBox="1"/>
+          <p:nvPr/>
+        </p:nvSpPr>
+        <p:spPr>
+          <a:xfrm>
+            <a:off x="6291072" y="1673352"/>
+            <a:ext cx="2377440" cy="1051560"/>
+          </a:xfrm>
+          <a:prstGeom prst="rect">
+            <a:avLst/>
+          </a:prstGeom>
+          <a:noFill/>
+        </p:spPr>
+        <p:txBody>
+          <a:bodyPr wrap="square">
+            <a:spAutoFit/>
+          </a:bodyPr>
+          <a:lstStyle/>
           <a:p>
             <a:pPr>
               <a:spcAft>
-                <a:spcPts val="1200"/>
-              </a:spcAft>
-            </a:pPr>
-            <a:r>
-              <a:rPr sz="1800" b="0" i="0">
+                <a:spcPts val="400"/>
+              </a:spcAft>
+            </a:pPr>
+            <a:r>
+              <a:rPr sz="1800" b="1" i="0">
+                <a:solidFill>
+                  <a:srgbClr val="00883A"/>
+                </a:solidFill>
+                <a:latin typeface="Arial"/>
+              </a:rPr>
+              <a:t>C3 </a:t>
+            </a:r>
+            <a:r>
+              <a:rPr sz="1700" b="0" i="0">
                 <a:solidFill>
                   <a:srgbClr val="1A1A1A"/>
                 </a:solidFill>
                 <a:latin typeface="Arial"/>
               </a:rPr>
-              <a:t>• questions grouped by RQ: value · creating · using · reviewing</a:t>
+              <a:t>Maintenance</a:t>
             </a:r>
           </a:p>
           <a:p>
             <a:pPr>
               <a:spcAft>
-                <a:spcPts val="1200"/>
-              </a:spcAft>
-            </a:pPr>
-            <a:r>
-              <a:rPr sz="1800" b="0" i="0">
+                <a:spcPts val="400"/>
+              </a:spcAft>
+            </a:pPr>
+            <a:r>
+              <a:rPr sz="1800" b="1" i="0">
+                <a:solidFill>
+                  <a:srgbClr val="00883A"/>
+                </a:solidFill>
+                <a:latin typeface="Arial"/>
+              </a:rPr>
+              <a:t>■ </a:t>
+            </a:r>
+            <a:r>
+              <a:rPr sz="1800" b="1" i="0">
+                <a:solidFill>
+                  <a:srgbClr val="5F6368"/>
+                </a:solidFill>
+                <a:latin typeface="Arial"/>
+              </a:rPr>
+              <a:t>▲ </a:t>
+            </a:r>
+          </a:p>
+        </p:txBody>
+      </p:sp>
+      <p:sp>
+        <p:nvSpPr>
+          <p:cNvPr id="141" name="Rounded Rectangle 140"/>
+          <p:cNvSpPr/>
+          <p:nvPr/>
+        </p:nvSpPr>
+        <p:spPr>
+          <a:xfrm>
+            <a:off x="8951976" y="1600200"/>
+            <a:ext cx="2587752" cy="1188720"/>
+          </a:xfrm>
+          <a:prstGeom prst="roundRect">
+            <a:avLst>
+              <a:gd name="adj" fmla="val 8000"/>
+            </a:avLst>
+          </a:prstGeom>
+          <a:solidFill>
+            <a:srgbClr val="F1F3F2"/>
+          </a:solidFill>
+          <a:ln>
+            <a:noFill/>
+          </a:ln>
+          <a:effectLst/>
+        </p:spPr>
+        <p:style>
+          <a:lnRef idx="1">
+            <a:schemeClr val="accent1"/>
+          </a:lnRef>
+          <a:fillRef idx="3">
+            <a:schemeClr val="accent1"/>
+          </a:fillRef>
+          <a:effectRef idx="2">
+            <a:schemeClr val="accent1"/>
+          </a:effectRef>
+          <a:fontRef idx="minor">
+            <a:schemeClr val="lt1"/>
+          </a:fontRef>
+        </p:style>
+        <p:txBody>
+          <a:bodyPr rtlCol="0" anchor="ctr"/>
+          <a:lstStyle/>
+          <a:p>
+            <a:pPr algn="ctr"/>
+          </a:p>
+        </p:txBody>
+      </p:sp>
+      <p:sp>
+        <p:nvSpPr>
+          <p:cNvPr id="142" name="TextBox 141"/>
+          <p:cNvSpPr txBox="1"/>
+          <p:nvPr/>
+        </p:nvSpPr>
+        <p:spPr>
+          <a:xfrm>
+            <a:off x="9061703" y="1673352"/>
+            <a:ext cx="2377440" cy="1051560"/>
+          </a:xfrm>
+          <a:prstGeom prst="rect">
+            <a:avLst/>
+          </a:prstGeom>
+          <a:noFill/>
+        </p:spPr>
+        <p:txBody>
+          <a:bodyPr wrap="square">
+            <a:spAutoFit/>
+          </a:bodyPr>
+          <a:lstStyle/>
+          <a:p>
+            <a:pPr>
+              <a:spcAft>
+                <a:spcPts val="400"/>
+              </a:spcAft>
+            </a:pPr>
+            <a:r>
+              <a:rPr sz="1800" b="1" i="0">
+                <a:solidFill>
+                  <a:srgbClr val="00883A"/>
+                </a:solidFill>
+                <a:latin typeface="Arial"/>
+              </a:rPr>
+              <a:t>C4 </a:t>
+            </a:r>
+            <a:r>
+              <a:rPr sz="1700" b="0" i="0">
                 <a:solidFill>
                   <a:srgbClr val="1A1A1A"/>
                 </a:solidFill>
                 <a:latin typeface="Arial"/>
               </a:rPr>
-              <a:t>• descriptive, then axial coding by 3 domain experts + 1 methodologist</a:t>
+              <a:t>Tacit knowledge</a:t>
             </a:r>
           </a:p>
           <a:p>
             <a:pPr>
               <a:spcAft>
-                <a:spcPts val="1200"/>
-              </a:spcAft>
-            </a:pPr>
-            <a:r>
-              <a:rPr sz="1800" b="0" i="0">
+                <a:spcPts val="400"/>
+              </a:spcAft>
+            </a:pPr>
+            <a:r>
+              <a:rPr sz="1800" b="1" i="0">
+                <a:solidFill>
+                  <a:srgbClr val="00883A"/>
+                </a:solidFill>
+                <a:latin typeface="Arial"/>
+              </a:rPr>
+              <a:t>■ </a:t>
+            </a:r>
+            <a:r>
+              <a:rPr sz="1800" b="1" i="0">
+                <a:solidFill>
+                  <a:srgbClr val="5F6368"/>
+                </a:solidFill>
+                <a:latin typeface="Arial"/>
+              </a:rPr>
+              <a:t>▲ </a:t>
+            </a:r>
+            <a:r>
+              <a:rPr sz="1800" b="1" i="0">
                 <a:solidFill>
                   <a:srgbClr val="1A1A1A"/>
                 </a:solidFill>
                 <a:latin typeface="Arial"/>
               </a:rPr>
-              <a:t>• themes show the range of experiences, not how common they are</a:t>
+              <a:t>★ </a:t>
+            </a:r>
+          </a:p>
+        </p:txBody>
+      </p:sp>
+      <p:sp>
+        <p:nvSpPr>
+          <p:cNvPr id="143" name="Rounded Rectangle 142"/>
+          <p:cNvSpPr/>
+          <p:nvPr/>
+        </p:nvSpPr>
+        <p:spPr>
+          <a:xfrm>
+            <a:off x="640080" y="2971800"/>
+            <a:ext cx="2587752" cy="1188720"/>
+          </a:xfrm>
+          <a:prstGeom prst="roundRect">
+            <a:avLst>
+              <a:gd name="adj" fmla="val 8000"/>
+            </a:avLst>
+          </a:prstGeom>
+          <a:solidFill>
+            <a:srgbClr val="F1F3F2"/>
+          </a:solidFill>
+          <a:ln>
+            <a:noFill/>
+          </a:ln>
+          <a:effectLst/>
+        </p:spPr>
+        <p:style>
+          <a:lnRef idx="1">
+            <a:schemeClr val="accent1"/>
+          </a:lnRef>
+          <a:fillRef idx="3">
+            <a:schemeClr val="accent1"/>
+          </a:fillRef>
+          <a:effectRef idx="2">
+            <a:schemeClr val="accent1"/>
+          </a:effectRef>
+          <a:fontRef idx="minor">
+            <a:schemeClr val="lt1"/>
+          </a:fontRef>
+        </p:style>
+        <p:txBody>
+          <a:bodyPr rtlCol="0" anchor="ctr"/>
+          <a:lstStyle/>
+          <a:p>
+            <a:pPr algn="ctr"/>
+          </a:p>
+        </p:txBody>
+      </p:sp>
+      <p:sp>
+        <p:nvSpPr>
+          <p:cNvPr id="144" name="TextBox 143"/>
+          <p:cNvSpPr txBox="1"/>
+          <p:nvPr/>
+        </p:nvSpPr>
+        <p:spPr>
+          <a:xfrm>
+            <a:off x="749808" y="3044952"/>
+            <a:ext cx="2377440" cy="1051560"/>
+          </a:xfrm>
+          <a:prstGeom prst="rect">
+            <a:avLst/>
+          </a:prstGeom>
+          <a:noFill/>
+        </p:spPr>
+        <p:txBody>
+          <a:bodyPr wrap="square">
+            <a:spAutoFit/>
+          </a:bodyPr>
+          <a:lstStyle/>
+          <a:p>
+            <a:pPr>
+              <a:spcAft>
+                <a:spcPts val="400"/>
+              </a:spcAft>
+            </a:pPr>
+            <a:r>
+              <a:rPr sz="1800" b="1" i="0">
+                <a:solidFill>
+                  <a:srgbClr val="00883A"/>
+                </a:solidFill>
+                <a:latin typeface="Arial"/>
+              </a:rPr>
+              <a:t>C5 </a:t>
+            </a:r>
+            <a:r>
+              <a:rPr sz="1700" b="0" i="0">
+                <a:solidFill>
+                  <a:srgbClr val="1A1A1A"/>
+                </a:solidFill>
+                <a:latin typeface="Arial"/>
+              </a:rPr>
+              <a:t>Doesn’t fit purpose</a:t>
+            </a:r>
+          </a:p>
+          <a:p>
+            <a:pPr>
+              <a:spcAft>
+                <a:spcPts val="400"/>
+              </a:spcAft>
+            </a:pPr>
+            <a:r>
+              <a:rPr sz="1800" b="1" i="0">
+                <a:solidFill>
+                  <a:srgbClr val="5F6368"/>
+                </a:solidFill>
+                <a:latin typeface="Arial"/>
+              </a:rPr>
+              <a:t>▲ </a:t>
+            </a:r>
+          </a:p>
+        </p:txBody>
+      </p:sp>
+      <p:sp>
+        <p:nvSpPr>
+          <p:cNvPr id="145" name="Rounded Rectangle 144"/>
+          <p:cNvSpPr/>
+          <p:nvPr/>
+        </p:nvSpPr>
+        <p:spPr>
+          <a:xfrm>
+            <a:off x="3410711" y="2971800"/>
+            <a:ext cx="2587752" cy="1188720"/>
+          </a:xfrm>
+          <a:prstGeom prst="roundRect">
+            <a:avLst>
+              <a:gd name="adj" fmla="val 8000"/>
+            </a:avLst>
+          </a:prstGeom>
+          <a:solidFill>
+            <a:srgbClr val="F1F3F2"/>
+          </a:solidFill>
+          <a:ln>
+            <a:noFill/>
+          </a:ln>
+          <a:effectLst/>
+        </p:spPr>
+        <p:style>
+          <a:lnRef idx="1">
+            <a:schemeClr val="accent1"/>
+          </a:lnRef>
+          <a:fillRef idx="3">
+            <a:schemeClr val="accent1"/>
+          </a:fillRef>
+          <a:effectRef idx="2">
+            <a:schemeClr val="accent1"/>
+          </a:effectRef>
+          <a:fontRef idx="minor">
+            <a:schemeClr val="lt1"/>
+          </a:fontRef>
+        </p:style>
+        <p:txBody>
+          <a:bodyPr rtlCol="0" anchor="ctr"/>
+          <a:lstStyle/>
+          <a:p>
+            <a:pPr algn="ctr"/>
+          </a:p>
+        </p:txBody>
+      </p:sp>
+      <p:sp>
+        <p:nvSpPr>
+          <p:cNvPr id="146" name="TextBox 145"/>
+          <p:cNvSpPr txBox="1"/>
+          <p:nvPr/>
+        </p:nvSpPr>
+        <p:spPr>
+          <a:xfrm>
+            <a:off x="3520439" y="3044952"/>
+            <a:ext cx="2377440" cy="1051560"/>
+          </a:xfrm>
+          <a:prstGeom prst="rect">
+            <a:avLst/>
+          </a:prstGeom>
+          <a:noFill/>
+        </p:spPr>
+        <p:txBody>
+          <a:bodyPr wrap="square">
+            <a:spAutoFit/>
+          </a:bodyPr>
+          <a:lstStyle/>
+          <a:p>
+            <a:pPr>
+              <a:spcAft>
+                <a:spcPts val="400"/>
+              </a:spcAft>
+            </a:pPr>
+            <a:r>
+              <a:rPr sz="1800" b="1" i="0">
+                <a:solidFill>
+                  <a:srgbClr val="00883A"/>
+                </a:solidFill>
+                <a:latin typeface="Arial"/>
+              </a:rPr>
+              <a:t>C6 </a:t>
+            </a:r>
+            <a:r>
+              <a:rPr sz="1700" b="0" i="0">
+                <a:solidFill>
+                  <a:srgbClr val="1A1A1A"/>
+                </a:solidFill>
+                <a:latin typeface="Arial"/>
+              </a:rPr>
+              <a:t>No standards / guidelines</a:t>
+            </a:r>
+          </a:p>
+          <a:p>
+            <a:pPr>
+              <a:spcAft>
+                <a:spcPts val="400"/>
+              </a:spcAft>
+            </a:pPr>
+            <a:r>
+              <a:rPr sz="1800" b="1" i="0">
+                <a:solidFill>
+                  <a:srgbClr val="00883A"/>
+                </a:solidFill>
+                <a:latin typeface="Arial"/>
+              </a:rPr>
+              <a:t>■ </a:t>
+            </a:r>
+            <a:r>
+              <a:rPr sz="1800" b="1" i="0">
+                <a:solidFill>
+                  <a:srgbClr val="1A1A1A"/>
+                </a:solidFill>
+                <a:latin typeface="Arial"/>
+              </a:rPr>
+              <a:t>★ </a:t>
+            </a:r>
+          </a:p>
+        </p:txBody>
+      </p:sp>
+      <p:sp>
+        <p:nvSpPr>
+          <p:cNvPr id="147" name="Rounded Rectangle 146"/>
+          <p:cNvSpPr/>
+          <p:nvPr/>
+        </p:nvSpPr>
+        <p:spPr>
+          <a:xfrm>
+            <a:off x="6181344" y="2971800"/>
+            <a:ext cx="2587752" cy="1188720"/>
+          </a:xfrm>
+          <a:prstGeom prst="roundRect">
+            <a:avLst>
+              <a:gd name="adj" fmla="val 8000"/>
+            </a:avLst>
+          </a:prstGeom>
+          <a:solidFill>
+            <a:srgbClr val="F1F3F2"/>
+          </a:solidFill>
+          <a:ln>
+            <a:noFill/>
+          </a:ln>
+          <a:effectLst/>
+        </p:spPr>
+        <p:style>
+          <a:lnRef idx="1">
+            <a:schemeClr val="accent1"/>
+          </a:lnRef>
+          <a:fillRef idx="3">
+            <a:schemeClr val="accent1"/>
+          </a:fillRef>
+          <a:effectRef idx="2">
+            <a:schemeClr val="accent1"/>
+          </a:effectRef>
+          <a:fontRef idx="minor">
+            <a:schemeClr val="lt1"/>
+          </a:fontRef>
+        </p:style>
+        <p:txBody>
+          <a:bodyPr rtlCol="0" anchor="ctr"/>
+          <a:lstStyle/>
+          <a:p>
+            <a:pPr algn="ctr"/>
+          </a:p>
+        </p:txBody>
+      </p:sp>
+      <p:sp>
+        <p:nvSpPr>
+          <p:cNvPr id="148" name="TextBox 147"/>
+          <p:cNvSpPr txBox="1"/>
+          <p:nvPr/>
+        </p:nvSpPr>
+        <p:spPr>
+          <a:xfrm>
+            <a:off x="6291072" y="3044952"/>
+            <a:ext cx="2377440" cy="1051560"/>
+          </a:xfrm>
+          <a:prstGeom prst="rect">
+            <a:avLst/>
+          </a:prstGeom>
+          <a:noFill/>
+        </p:spPr>
+        <p:txBody>
+          <a:bodyPr wrap="square">
+            <a:spAutoFit/>
+          </a:bodyPr>
+          <a:lstStyle/>
+          <a:p>
+            <a:pPr>
+              <a:spcAft>
+                <a:spcPts val="400"/>
+              </a:spcAft>
+            </a:pPr>
+            <a:r>
+              <a:rPr sz="1800" b="1" i="0">
+                <a:solidFill>
+                  <a:srgbClr val="00883A"/>
+                </a:solidFill>
+                <a:latin typeface="Arial"/>
+              </a:rPr>
+              <a:t>C7 </a:t>
+            </a:r>
+            <a:r>
+              <a:rPr sz="1700" b="0" i="0">
+                <a:solidFill>
+                  <a:srgbClr val="1A1A1A"/>
+                </a:solidFill>
+                <a:latin typeface="Arial"/>
+              </a:rPr>
+              <a:t>Hosting</a:t>
+            </a:r>
+          </a:p>
+          <a:p>
+            <a:pPr>
+              <a:spcAft>
+                <a:spcPts val="400"/>
+              </a:spcAft>
+            </a:pPr>
+            <a:r>
+              <a:rPr sz="1800" b="1" i="0">
+                <a:solidFill>
+                  <a:srgbClr val="00883A"/>
+                </a:solidFill>
+                <a:latin typeface="Arial"/>
+              </a:rPr>
+              <a:t>■ </a:t>
+            </a:r>
+            <a:r>
+              <a:rPr sz="1800" b="1" i="0">
+                <a:solidFill>
+                  <a:srgbClr val="5F6368"/>
+                </a:solidFill>
+                <a:latin typeface="Arial"/>
+              </a:rPr>
+              <a:t>▲ </a:t>
+            </a:r>
+          </a:p>
+        </p:txBody>
+      </p:sp>
+      <p:sp>
+        <p:nvSpPr>
+          <p:cNvPr id="149" name="Rounded Rectangle 148"/>
+          <p:cNvSpPr/>
+          <p:nvPr/>
+        </p:nvSpPr>
+        <p:spPr>
+          <a:xfrm>
+            <a:off x="8951976" y="2971800"/>
+            <a:ext cx="2587752" cy="1188720"/>
+          </a:xfrm>
+          <a:prstGeom prst="roundRect">
+            <a:avLst>
+              <a:gd name="adj" fmla="val 8000"/>
+            </a:avLst>
+          </a:prstGeom>
+          <a:solidFill>
+            <a:srgbClr val="F1F3F2"/>
+          </a:solidFill>
+          <a:ln>
+            <a:noFill/>
+          </a:ln>
+          <a:effectLst/>
+        </p:spPr>
+        <p:style>
+          <a:lnRef idx="1">
+            <a:schemeClr val="accent1"/>
+          </a:lnRef>
+          <a:fillRef idx="3">
+            <a:schemeClr val="accent1"/>
+          </a:fillRef>
+          <a:effectRef idx="2">
+            <a:schemeClr val="accent1"/>
+          </a:effectRef>
+          <a:fontRef idx="minor">
+            <a:schemeClr val="lt1"/>
+          </a:fontRef>
+        </p:style>
+        <p:txBody>
+          <a:bodyPr rtlCol="0" anchor="ctr"/>
+          <a:lstStyle/>
+          <a:p>
+            <a:pPr algn="ctr"/>
+          </a:p>
+        </p:txBody>
+      </p:sp>
+      <p:sp>
+        <p:nvSpPr>
+          <p:cNvPr id="150" name="TextBox 149"/>
+          <p:cNvSpPr txBox="1"/>
+          <p:nvPr/>
+        </p:nvSpPr>
+        <p:spPr>
+          <a:xfrm>
+            <a:off x="9061703" y="3044952"/>
+            <a:ext cx="2377440" cy="1051560"/>
+          </a:xfrm>
+          <a:prstGeom prst="rect">
+            <a:avLst/>
+          </a:prstGeom>
+          <a:noFill/>
+        </p:spPr>
+        <p:txBody>
+          <a:bodyPr wrap="square">
+            <a:spAutoFit/>
+          </a:bodyPr>
+          <a:lstStyle/>
+          <a:p>
+            <a:pPr>
+              <a:spcAft>
+                <a:spcPts val="400"/>
+              </a:spcAft>
+            </a:pPr>
+            <a:r>
+              <a:rPr sz="1800" b="1" i="0">
+                <a:solidFill>
+                  <a:srgbClr val="00883A"/>
+                </a:solidFill>
+                <a:latin typeface="Arial"/>
+              </a:rPr>
+              <a:t>C8 </a:t>
+            </a:r>
+            <a:r>
+              <a:rPr sz="1700" b="0" i="0">
+                <a:solidFill>
+                  <a:srgbClr val="1A1A1A"/>
+                </a:solidFill>
+                <a:latin typeface="Arial"/>
+              </a:rPr>
+              <a:t>Double-blind review</a:t>
+            </a:r>
+          </a:p>
+          <a:p>
+            <a:pPr>
+              <a:spcAft>
+                <a:spcPts val="400"/>
+              </a:spcAft>
+            </a:pPr>
+            <a:r>
+              <a:rPr sz="1800" b="1" i="0">
+                <a:solidFill>
+                  <a:srgbClr val="00883A"/>
+                </a:solidFill>
+                <a:latin typeface="Arial"/>
+              </a:rPr>
+              <a:t>■ </a:t>
+            </a:r>
+          </a:p>
+        </p:txBody>
+      </p:sp>
+      <p:sp>
+        <p:nvSpPr>
+          <p:cNvPr id="151" name="Rounded Rectangle 150"/>
+          <p:cNvSpPr/>
+          <p:nvPr/>
+        </p:nvSpPr>
+        <p:spPr>
+          <a:xfrm>
+            <a:off x="640080" y="4343400"/>
+            <a:ext cx="2587752" cy="1188720"/>
+          </a:xfrm>
+          <a:prstGeom prst="roundRect">
+            <a:avLst>
+              <a:gd name="adj" fmla="val 8000"/>
+            </a:avLst>
+          </a:prstGeom>
+          <a:solidFill>
+            <a:srgbClr val="F1F3F2"/>
+          </a:solidFill>
+          <a:ln>
+            <a:noFill/>
+          </a:ln>
+          <a:effectLst/>
+        </p:spPr>
+        <p:style>
+          <a:lnRef idx="1">
+            <a:schemeClr val="accent1"/>
+          </a:lnRef>
+          <a:fillRef idx="3">
+            <a:schemeClr val="accent1"/>
+          </a:fillRef>
+          <a:effectRef idx="2">
+            <a:schemeClr val="accent1"/>
+          </a:effectRef>
+          <a:fontRef idx="minor">
+            <a:schemeClr val="lt1"/>
+          </a:fontRef>
+        </p:style>
+        <p:txBody>
+          <a:bodyPr rtlCol="0" anchor="ctr"/>
+          <a:lstStyle/>
+          <a:p>
+            <a:pPr algn="ctr"/>
+          </a:p>
+        </p:txBody>
+      </p:sp>
+      <p:sp>
+        <p:nvSpPr>
+          <p:cNvPr id="152" name="TextBox 151"/>
+          <p:cNvSpPr txBox="1"/>
+          <p:nvPr/>
+        </p:nvSpPr>
+        <p:spPr>
+          <a:xfrm>
+            <a:off x="749808" y="4416552"/>
+            <a:ext cx="2377440" cy="1051560"/>
+          </a:xfrm>
+          <a:prstGeom prst="rect">
+            <a:avLst/>
+          </a:prstGeom>
+          <a:noFill/>
+        </p:spPr>
+        <p:txBody>
+          <a:bodyPr wrap="square">
+            <a:spAutoFit/>
+          </a:bodyPr>
+          <a:lstStyle/>
+          <a:p>
+            <a:pPr>
+              <a:spcAft>
+                <a:spcPts val="400"/>
+              </a:spcAft>
+            </a:pPr>
+            <a:r>
+              <a:rPr sz="1800" b="1" i="0">
+                <a:solidFill>
+                  <a:srgbClr val="00883A"/>
+                </a:solidFill>
+                <a:latin typeface="Arial"/>
+              </a:rPr>
+              <a:t>C9 </a:t>
+            </a:r>
+            <a:r>
+              <a:rPr sz="1700" b="0" i="0">
+                <a:solidFill>
+                  <a:srgbClr val="1A1A1A"/>
+                </a:solidFill>
+                <a:latin typeface="Arial"/>
+              </a:rPr>
+              <a:t>External constraints</a:t>
+            </a:r>
+          </a:p>
+          <a:p>
+            <a:pPr>
+              <a:spcAft>
+                <a:spcPts val="400"/>
+              </a:spcAft>
+            </a:pPr>
+            <a:r>
+              <a:rPr sz="1800" b="1" i="0">
+                <a:solidFill>
+                  <a:srgbClr val="00883A"/>
+                </a:solidFill>
+                <a:latin typeface="Arial"/>
+              </a:rPr>
+              <a:t>■ </a:t>
+            </a:r>
+            <a:r>
+              <a:rPr sz="1800" b="1" i="0">
+                <a:solidFill>
+                  <a:srgbClr val="5F6368"/>
+                </a:solidFill>
+                <a:latin typeface="Arial"/>
+              </a:rPr>
+              <a:t>▲ </a:t>
+            </a:r>
+            <a:r>
+              <a:rPr sz="1800" b="1" i="0">
+                <a:solidFill>
+                  <a:srgbClr val="1A1A1A"/>
+                </a:solidFill>
+                <a:latin typeface="Arial"/>
+              </a:rPr>
+              <a:t>★ </a:t>
+            </a:r>
+          </a:p>
+        </p:txBody>
+      </p:sp>
+      <p:sp>
+        <p:nvSpPr>
+          <p:cNvPr id="153" name="Rounded Rectangle 152"/>
+          <p:cNvSpPr/>
+          <p:nvPr/>
+        </p:nvSpPr>
+        <p:spPr>
+          <a:xfrm>
+            <a:off x="3410711" y="4343400"/>
+            <a:ext cx="2587752" cy="1188720"/>
+          </a:xfrm>
+          <a:prstGeom prst="roundRect">
+            <a:avLst>
+              <a:gd name="adj" fmla="val 8000"/>
+            </a:avLst>
+          </a:prstGeom>
+          <a:solidFill>
+            <a:srgbClr val="F1F3F2"/>
+          </a:solidFill>
+          <a:ln>
+            <a:noFill/>
+          </a:ln>
+          <a:effectLst/>
+        </p:spPr>
+        <p:style>
+          <a:lnRef idx="1">
+            <a:schemeClr val="accent1"/>
+          </a:lnRef>
+          <a:fillRef idx="3">
+            <a:schemeClr val="accent1"/>
+          </a:fillRef>
+          <a:effectRef idx="2">
+            <a:schemeClr val="accent1"/>
+          </a:effectRef>
+          <a:fontRef idx="minor">
+            <a:schemeClr val="lt1"/>
+          </a:fontRef>
+        </p:style>
+        <p:txBody>
+          <a:bodyPr rtlCol="0" anchor="ctr"/>
+          <a:lstStyle/>
+          <a:p>
+            <a:pPr algn="ctr"/>
+          </a:p>
+        </p:txBody>
+      </p:sp>
+      <p:sp>
+        <p:nvSpPr>
+          <p:cNvPr id="154" name="TextBox 153"/>
+          <p:cNvSpPr txBox="1"/>
+          <p:nvPr/>
+        </p:nvSpPr>
+        <p:spPr>
+          <a:xfrm>
+            <a:off x="3520439" y="4416552"/>
+            <a:ext cx="2377440" cy="1051560"/>
+          </a:xfrm>
+          <a:prstGeom prst="rect">
+            <a:avLst/>
+          </a:prstGeom>
+          <a:noFill/>
+        </p:spPr>
+        <p:txBody>
+          <a:bodyPr wrap="square">
+            <a:spAutoFit/>
+          </a:bodyPr>
+          <a:lstStyle/>
+          <a:p>
+            <a:pPr>
+              <a:spcAft>
+                <a:spcPts val="400"/>
+              </a:spcAft>
+            </a:pPr>
+            <a:r>
+              <a:rPr sz="1800" b="1" i="0">
+                <a:solidFill>
+                  <a:srgbClr val="00883A"/>
+                </a:solidFill>
+                <a:latin typeface="Arial"/>
+              </a:rPr>
+              <a:t>C10 </a:t>
+            </a:r>
+            <a:r>
+              <a:rPr sz="1700" b="0" i="0">
+                <a:solidFill>
+                  <a:srgbClr val="1A1A1A"/>
+                </a:solidFill>
+                <a:latin typeface="Arial"/>
+              </a:rPr>
+              <a:t>No reviewer incentives</a:t>
+            </a:r>
+          </a:p>
+          <a:p>
+            <a:pPr>
+              <a:spcAft>
+                <a:spcPts val="400"/>
+              </a:spcAft>
+            </a:pPr>
+            <a:r>
+              <a:rPr sz="1800" b="1" i="0">
+                <a:solidFill>
+                  <a:srgbClr val="1A1A1A"/>
+                </a:solidFill>
+                <a:latin typeface="Arial"/>
+              </a:rPr>
+              <a:t>★ </a:t>
+            </a:r>
+          </a:p>
+        </p:txBody>
+      </p:sp>
+      <p:sp>
+        <p:nvSpPr>
+          <p:cNvPr id="155" name="Rounded Rectangle 154"/>
+          <p:cNvSpPr/>
+          <p:nvPr/>
+        </p:nvSpPr>
+        <p:spPr>
+          <a:xfrm>
+            <a:off x="6181344" y="4343400"/>
+            <a:ext cx="2587752" cy="1188720"/>
+          </a:xfrm>
+          <a:prstGeom prst="roundRect">
+            <a:avLst>
+              <a:gd name="adj" fmla="val 8000"/>
+            </a:avLst>
+          </a:prstGeom>
+          <a:solidFill>
+            <a:srgbClr val="F1F3F2"/>
+          </a:solidFill>
+          <a:ln>
+            <a:noFill/>
+          </a:ln>
+          <a:effectLst/>
+        </p:spPr>
+        <p:style>
+          <a:lnRef idx="1">
+            <a:schemeClr val="accent1"/>
+          </a:lnRef>
+          <a:fillRef idx="3">
+            <a:schemeClr val="accent1"/>
+          </a:fillRef>
+          <a:effectRef idx="2">
+            <a:schemeClr val="accent1"/>
+          </a:effectRef>
+          <a:fontRef idx="minor">
+            <a:schemeClr val="lt1"/>
+          </a:fontRef>
+        </p:style>
+        <p:txBody>
+          <a:bodyPr rtlCol="0" anchor="ctr"/>
+          <a:lstStyle/>
+          <a:p>
+            <a:pPr algn="ctr"/>
+          </a:p>
+        </p:txBody>
+      </p:sp>
+      <p:sp>
+        <p:nvSpPr>
+          <p:cNvPr id="156" name="TextBox 155"/>
+          <p:cNvSpPr txBox="1"/>
+          <p:nvPr/>
+        </p:nvSpPr>
+        <p:spPr>
+          <a:xfrm>
+            <a:off x="6291072" y="4416552"/>
+            <a:ext cx="2377440" cy="1051560"/>
+          </a:xfrm>
+          <a:prstGeom prst="rect">
+            <a:avLst/>
+          </a:prstGeom>
+          <a:noFill/>
+        </p:spPr>
+        <p:txBody>
+          <a:bodyPr wrap="square">
+            <a:spAutoFit/>
+          </a:bodyPr>
+          <a:lstStyle/>
+          <a:p>
+            <a:pPr>
+              <a:spcAft>
+                <a:spcPts val="400"/>
+              </a:spcAft>
+            </a:pPr>
+            <a:r>
+              <a:rPr sz="1800" b="1" i="0">
+                <a:solidFill>
+                  <a:srgbClr val="00883A"/>
+                </a:solidFill>
+                <a:latin typeface="Arial"/>
+              </a:rPr>
+              <a:t>C11 </a:t>
+            </a:r>
+            <a:r>
+              <a:rPr sz="1700" b="0" i="0">
+                <a:solidFill>
+                  <a:srgbClr val="1A1A1A"/>
+                </a:solidFill>
+                <a:latin typeface="Arial"/>
+              </a:rPr>
+              <a:t>Technical obstacles</a:t>
+            </a:r>
+          </a:p>
+          <a:p>
+            <a:pPr>
+              <a:spcAft>
+                <a:spcPts val="400"/>
+              </a:spcAft>
+            </a:pPr>
+            <a:r>
+              <a:rPr sz="1800" b="1" i="0">
+                <a:solidFill>
+                  <a:srgbClr val="1A1A1A"/>
+                </a:solidFill>
+                <a:latin typeface="Arial"/>
+              </a:rPr>
+              <a:t>★ </a:t>
+            </a:r>
+          </a:p>
+        </p:txBody>
+      </p:sp>
+      <p:sp>
+        <p:nvSpPr>
+          <p:cNvPr id="157" name="Rounded Rectangle 156"/>
+          <p:cNvSpPr/>
+          <p:nvPr/>
+        </p:nvSpPr>
+        <p:spPr>
+          <a:xfrm>
+            <a:off x="8951976" y="4343400"/>
+            <a:ext cx="2587752" cy="1188720"/>
+          </a:xfrm>
+          <a:prstGeom prst="roundRect">
+            <a:avLst>
+              <a:gd name="adj" fmla="val 8000"/>
+            </a:avLst>
+          </a:prstGeom>
+          <a:solidFill>
+            <a:srgbClr val="F1F3F2"/>
+          </a:solidFill>
+          <a:ln>
+            <a:noFill/>
+          </a:ln>
+          <a:effectLst/>
+        </p:spPr>
+        <p:style>
+          <a:lnRef idx="1">
+            <a:schemeClr val="accent1"/>
+          </a:lnRef>
+          <a:fillRef idx="3">
+            <a:schemeClr val="accent1"/>
+          </a:fillRef>
+          <a:effectRef idx="2">
+            <a:schemeClr val="accent1"/>
+          </a:effectRef>
+          <a:fontRef idx="minor">
+            <a:schemeClr val="lt1"/>
+          </a:fontRef>
+        </p:style>
+        <p:txBody>
+          <a:bodyPr rtlCol="0" anchor="ctr"/>
+          <a:lstStyle/>
+          <a:p>
+            <a:pPr algn="ctr"/>
+          </a:p>
+        </p:txBody>
+      </p:sp>
+      <p:sp>
+        <p:nvSpPr>
+          <p:cNvPr id="158" name="TextBox 157"/>
+          <p:cNvSpPr txBox="1"/>
+          <p:nvPr/>
+        </p:nvSpPr>
+        <p:spPr>
+          <a:xfrm>
+            <a:off x="9061703" y="4416552"/>
+            <a:ext cx="2377440" cy="1051560"/>
+          </a:xfrm>
+          <a:prstGeom prst="rect">
+            <a:avLst/>
+          </a:prstGeom>
+          <a:noFill/>
+        </p:spPr>
+        <p:txBody>
+          <a:bodyPr wrap="square">
+            <a:spAutoFit/>
+          </a:bodyPr>
+          <a:lstStyle/>
+          <a:p>
+            <a:pPr>
+              <a:spcAft>
+                <a:spcPts val="400"/>
+              </a:spcAft>
+            </a:pPr>
+            <a:r>
+              <a:rPr sz="1800" b="1" i="0">
+                <a:solidFill>
+                  <a:srgbClr val="00883A"/>
+                </a:solidFill>
+                <a:latin typeface="Arial"/>
+              </a:rPr>
+              <a:t>C12 </a:t>
+            </a:r>
+            <a:r>
+              <a:rPr sz="1700" b="0" i="0">
+                <a:solidFill>
+                  <a:srgbClr val="1A1A1A"/>
+                </a:solidFill>
+                <a:latin typeface="Arial"/>
+              </a:rPr>
+              <a:t>Limited communication</a:t>
+            </a:r>
+          </a:p>
+          <a:p>
+            <a:pPr>
+              <a:spcAft>
+                <a:spcPts val="400"/>
+              </a:spcAft>
+            </a:pPr>
+            <a:r>
+              <a:rPr sz="1800" b="1" i="0">
+                <a:solidFill>
+                  <a:srgbClr val="1A1A1A"/>
+                </a:solidFill>
+                <a:latin typeface="Arial"/>
+              </a:rPr>
+              <a:t>★ </a:t>
+            </a:r>
+          </a:p>
+        </p:txBody>
+      </p:sp>
+      <p:sp>
+        <p:nvSpPr>
+          <p:cNvPr id="159" name="TextBox 158"/>
+          <p:cNvSpPr txBox="1"/>
+          <p:nvPr/>
+        </p:nvSpPr>
+        <p:spPr>
+          <a:xfrm>
+            <a:off x="640080" y="5806440"/>
+            <a:ext cx="10908792" cy="457200"/>
+          </a:xfrm>
+          <a:prstGeom prst="rect">
+            <a:avLst/>
+          </a:prstGeom>
+          <a:noFill/>
+        </p:spPr>
+        <p:txBody>
+          <a:bodyPr wrap="square">
+            <a:spAutoFit/>
+          </a:bodyPr>
+          <a:lstStyle/>
+          <a:p>
+            <a:pPr>
+              <a:spcAft>
+                <a:spcPts val="600"/>
+              </a:spcAft>
+            </a:pPr>
+            <a:r>
+              <a:rPr sz="1600" b="1" i="0">
+                <a:solidFill>
+                  <a:srgbClr val="00883A"/>
+                </a:solidFill>
+                <a:latin typeface="Arial"/>
+              </a:rPr>
+              <a:t>■ </a:t>
+            </a:r>
+            <a:r>
+              <a:rPr sz="1600" b="0" i="0">
+                <a:solidFill>
+                  <a:srgbClr val="5F6368"/>
+                </a:solidFill>
+                <a:latin typeface="Arial"/>
+              </a:rPr>
+              <a:t>creator   </a:t>
+            </a:r>
+            <a:r>
+              <a:rPr sz="1600" b="1" i="0">
+                <a:solidFill>
+                  <a:srgbClr val="5F6368"/>
+                </a:solidFill>
+                <a:latin typeface="Arial"/>
+              </a:rPr>
+              <a:t>▲ </a:t>
+            </a:r>
+            <a:r>
+              <a:rPr sz="1600" b="0" i="0">
+                <a:solidFill>
+                  <a:srgbClr val="5F6368"/>
+                </a:solidFill>
+                <a:latin typeface="Arial"/>
+              </a:rPr>
+              <a:t>user   </a:t>
+            </a:r>
+            <a:r>
+              <a:rPr sz="1600" b="1" i="0">
+                <a:solidFill>
+                  <a:srgbClr val="1A1A1A"/>
+                </a:solidFill>
+                <a:latin typeface="Arial"/>
+              </a:rPr>
+              <a:t>★ </a:t>
+            </a:r>
+            <a:r>
+              <a:rPr sz="1600" b="0" i="0">
+                <a:solidFill>
+                  <a:srgbClr val="5F6368"/>
+                </a:solidFill>
+                <a:latin typeface="Arial"/>
+              </a:rPr>
+              <a:t>reviewer</a:t>
             </a:r>
           </a:p>
         </p:txBody>
@@ -45360,1671 +46427,6 @@
 </file>
 
 <file path=ppt/slides/slide70.xml><?xml version="1.0" encoding="utf-8"?>
-<p:sld xmlns:a="http://schemas.openxmlformats.org/drawingml/2006/main" xmlns:p="http://schemas.openxmlformats.org/presentationml/2006/main" xmlns:r="http://schemas.openxmlformats.org/officeDocument/2006/relationships">
-  <p:cSld>
-    <p:spTree>
-      <p:nvGrpSpPr>
-        <p:cNvPr id="1" name=""/>
-        <p:cNvGrpSpPr/>
-        <p:nvPr/>
-      </p:nvGrpSpPr>
-      <p:grpSpPr/>
-      <p:sp>
-        <p:nvSpPr>
-          <p:cNvPr id="131" name="Google Shape;131;p16"/>
-          <p:cNvSpPr txBox="1"/>
-          <p:nvPr/>
-        </p:nvSpPr>
-        <p:spPr>
-          <a:xfrm>
-            <a:off x="640080" y="365760"/>
-            <a:ext cx="10911600" cy="822900"/>
-          </a:xfrm>
-          <a:prstGeom prst="rect">
-            <a:avLst/>
-          </a:prstGeom>
-          <a:noFill/>
-          <a:ln>
-            <a:noFill/>
-          </a:ln>
-        </p:spPr>
-        <p:txBody>
-          <a:bodyPr anchorCtr="0" anchor="ctr" bIns="0" lIns="0" spcFirstLastPara="1" rIns="0" wrap="square" tIns="0">
-            <a:noAutofit/>
-          </a:bodyPr>
-          <a:lstStyle/>
-          <a:p>
-            <a:pPr indent="0" lvl="0" marL="0" marR="0" rtl="0" algn="l">
-              <a:spcBef>
-                <a:spcPts val="0"/>
-              </a:spcBef>
-              <a:spcAft>
-                <a:spcPts val="0"/>
-              </a:spcAft>
-              <a:buClr>
-                <a:srgbClr val="00883A"/>
-              </a:buClr>
-              <a:buSzPts val="4000"/>
-              <a:buFont typeface="Arial"/>
-              <a:buNone/>
-            </a:pPr>
-            <a:r>
-              <a:rPr b="1" i="0" lang="en-US" sz="4000" u="none" cap="none" strike="noStrike">
-                <a:solidFill>
-                  <a:srgbClr val="00883A"/>
-                </a:solidFill>
-                <a:latin typeface="Arial"/>
-                <a:ea typeface="Arial"/>
-                <a:cs typeface="Arial"/>
-                <a:sym typeface="Arial"/>
-              </a:rPr>
-              <a:t>Results</a:t>
-            </a:r>
-            <a:endParaRPr b="0" i="0" sz="4000" u="none" cap="none" strike="noStrike">
-              <a:solidFill>
-                <a:schemeClr val="dk1"/>
-              </a:solidFill>
-              <a:latin typeface="Arial"/>
-              <a:ea typeface="Arial"/>
-              <a:cs typeface="Arial"/>
-              <a:sym typeface="Arial"/>
-            </a:endParaRPr>
-          </a:p>
-        </p:txBody>
-      </p:sp>
-      <p:sp>
-        <p:nvSpPr>
-          <p:cNvPr id="133" name="Google Shape;133;p16"/>
-          <p:cNvSpPr txBox="1"/>
-          <p:nvPr>
-            <p:ph idx="4294967295" type="sldNum"/>
-          </p:nvPr>
-        </p:nvSpPr>
-        <p:spPr>
-          <a:xfrm>
-            <a:off x="11247120" y="6355080"/>
-            <a:ext cx="548700" cy="320100"/>
-          </a:xfrm>
-          <a:prstGeom prst="rect">
-            <a:avLst/>
-          </a:prstGeom>
-          <a:noFill/>
-          <a:ln>
-            <a:noFill/>
-          </a:ln>
-        </p:spPr>
-        <p:txBody>
-          <a:bodyPr anchorCtr="0" anchor="t" bIns="45700" lIns="91425" spcFirstLastPara="1" rIns="91425" wrap="square" tIns="45700">
-            <a:noAutofit/>
-          </a:bodyPr>
-          <a:lstStyle/>
-          <a:p>
-            <a:pPr indent="0" lvl="0" marL="0" marR="0" rtl="0" algn="l">
-              <a:spcBef>
-                <a:spcPts val="0"/>
-              </a:spcBef>
-              <a:spcAft>
-                <a:spcPts val="0"/>
-              </a:spcAft>
-              <a:buNone/>
-            </a:pPr>
-            <a:fld id="{00000000-1234-1234-1234-123412341234}" type="slidenum">
-              <a:rPr b="0" i="0" lang="en-US" sz="1100" u="none" cap="none" strike="noStrike">
-                <a:solidFill>
-                  <a:srgbClr val="5F6368"/>
-                </a:solidFill>
-                <a:latin typeface="Arial"/>
-                <a:ea typeface="Arial"/>
-                <a:cs typeface="Arial"/>
-                <a:sym typeface="Arial"/>
-              </a:rPr>
-              <a:t>‹#›</a:t>
-            </a:fld>
-            <a:endParaRPr b="0" i="0" sz="1100" u="none" cap="none" strike="noStrike">
-              <a:solidFill>
-                <a:srgbClr val="5F6368"/>
-              </a:solidFill>
-              <a:latin typeface="Arial"/>
-              <a:ea typeface="Arial"/>
-              <a:cs typeface="Arial"/>
-              <a:sym typeface="Arial"/>
-            </a:endParaRPr>
-          </a:p>
-        </p:txBody>
-      </p:sp>
-      <p:sp>
-        <p:nvSpPr>
-          <p:cNvPr id="134" name="TextBox 133"/>
-          <p:cNvSpPr txBox="1"/>
-          <p:nvPr/>
-        </p:nvSpPr>
-        <p:spPr>
-          <a:xfrm>
-            <a:off x="640080" y="1097280"/>
-            <a:ext cx="9144000" cy="365760"/>
-          </a:xfrm>
-          <a:prstGeom prst="rect">
-            <a:avLst/>
-          </a:prstGeom>
-          <a:noFill/>
-        </p:spPr>
-        <p:txBody>
-          <a:bodyPr wrap="square">
-            <a:spAutoFit/>
-          </a:bodyPr>
-          <a:lstStyle/>
-          <a:p>
-            <a:pPr>
-              <a:spcAft>
-                <a:spcPts val="600"/>
-              </a:spcAft>
-            </a:pPr>
-            <a:r>
-              <a:rPr sz="1600" b="1" i="0">
-                <a:solidFill>
-                  <a:srgbClr val="5F6368"/>
-                </a:solidFill>
-                <a:latin typeface="Arial"/>
-              </a:rPr>
-              <a:t>RQ2 · Challenges of creating, sharing, using and reviewing (Table 4, pp. 14-15)</a:t>
-            </a:r>
-          </a:p>
-        </p:txBody>
-      </p:sp>
-      <p:sp>
-        <p:nvSpPr>
-          <p:cNvPr id="135" name="Rounded Rectangle 134"/>
-          <p:cNvSpPr/>
-          <p:nvPr/>
-        </p:nvSpPr>
-        <p:spPr>
-          <a:xfrm>
-            <a:off x="640080" y="1600200"/>
-            <a:ext cx="2587752" cy="1188720"/>
-          </a:xfrm>
-          <a:prstGeom prst="roundRect">
-            <a:avLst>
-              <a:gd name="adj" fmla="val 8000"/>
-            </a:avLst>
-          </a:prstGeom>
-          <a:solidFill>
-            <a:srgbClr val="F1F3F2"/>
-          </a:solidFill>
-          <a:ln>
-            <a:noFill/>
-          </a:ln>
-          <a:effectLst/>
-        </p:spPr>
-        <p:style>
-          <a:lnRef idx="1">
-            <a:schemeClr val="accent1"/>
-          </a:lnRef>
-          <a:fillRef idx="3">
-            <a:schemeClr val="accent1"/>
-          </a:fillRef>
-          <a:effectRef idx="2">
-            <a:schemeClr val="accent1"/>
-          </a:effectRef>
-          <a:fontRef idx="minor">
-            <a:schemeClr val="lt1"/>
-          </a:fontRef>
-        </p:style>
-        <p:txBody>
-          <a:bodyPr rtlCol="0" anchor="ctr"/>
-          <a:lstStyle/>
-          <a:p>
-            <a:pPr algn="ctr"/>
-          </a:p>
-        </p:txBody>
-      </p:sp>
-      <p:sp>
-        <p:nvSpPr>
-          <p:cNvPr id="136" name="TextBox 135"/>
-          <p:cNvSpPr txBox="1"/>
-          <p:nvPr/>
-        </p:nvSpPr>
-        <p:spPr>
-          <a:xfrm>
-            <a:off x="749808" y="1673352"/>
-            <a:ext cx="2377440" cy="1051560"/>
-          </a:xfrm>
-          <a:prstGeom prst="rect">
-            <a:avLst/>
-          </a:prstGeom>
-          <a:noFill/>
-        </p:spPr>
-        <p:txBody>
-          <a:bodyPr wrap="square">
-            <a:spAutoFit/>
-          </a:bodyPr>
-          <a:lstStyle/>
-          <a:p>
-            <a:pPr>
-              <a:spcAft>
-                <a:spcPts val="400"/>
-              </a:spcAft>
-            </a:pPr>
-            <a:r>
-              <a:rPr sz="1800" b="1" i="0">
-                <a:solidFill>
-                  <a:srgbClr val="00883A"/>
-                </a:solidFill>
-                <a:latin typeface="Arial"/>
-              </a:rPr>
-              <a:t>C1 </a:t>
-            </a:r>
-            <a:r>
-              <a:rPr sz="1700" b="0" i="0">
-                <a:solidFill>
-                  <a:srgbClr val="1A1A1A"/>
-                </a:solidFill>
-                <a:latin typeface="Arial"/>
-              </a:rPr>
-              <a:t>Not worth it</a:t>
-            </a:r>
-          </a:p>
-          <a:p>
-            <a:pPr>
-              <a:spcAft>
-                <a:spcPts val="400"/>
-              </a:spcAft>
-            </a:pPr>
-            <a:r>
-              <a:rPr sz="1800" b="1" i="0">
-                <a:solidFill>
-                  <a:srgbClr val="00883A"/>
-                </a:solidFill>
-                <a:latin typeface="Arial"/>
-              </a:rPr>
-              <a:t>■ </a:t>
-            </a:r>
-          </a:p>
-        </p:txBody>
-      </p:sp>
-      <p:sp>
-        <p:nvSpPr>
-          <p:cNvPr id="137" name="Rounded Rectangle 136"/>
-          <p:cNvSpPr/>
-          <p:nvPr/>
-        </p:nvSpPr>
-        <p:spPr>
-          <a:xfrm>
-            <a:off x="3410711" y="1600200"/>
-            <a:ext cx="2587752" cy="1188720"/>
-          </a:xfrm>
-          <a:prstGeom prst="roundRect">
-            <a:avLst>
-              <a:gd name="adj" fmla="val 8000"/>
-            </a:avLst>
-          </a:prstGeom>
-          <a:solidFill>
-            <a:srgbClr val="F1F3F2"/>
-          </a:solidFill>
-          <a:ln>
-            <a:noFill/>
-          </a:ln>
-          <a:effectLst/>
-        </p:spPr>
-        <p:style>
-          <a:lnRef idx="1">
-            <a:schemeClr val="accent1"/>
-          </a:lnRef>
-          <a:fillRef idx="3">
-            <a:schemeClr val="accent1"/>
-          </a:fillRef>
-          <a:effectRef idx="2">
-            <a:schemeClr val="accent1"/>
-          </a:effectRef>
-          <a:fontRef idx="minor">
-            <a:schemeClr val="lt1"/>
-          </a:fontRef>
-        </p:style>
-        <p:txBody>
-          <a:bodyPr rtlCol="0" anchor="ctr"/>
-          <a:lstStyle/>
-          <a:p>
-            <a:pPr algn="ctr"/>
-          </a:p>
-        </p:txBody>
-      </p:sp>
-      <p:sp>
-        <p:nvSpPr>
-          <p:cNvPr id="138" name="TextBox 137"/>
-          <p:cNvSpPr txBox="1"/>
-          <p:nvPr/>
-        </p:nvSpPr>
-        <p:spPr>
-          <a:xfrm>
-            <a:off x="3520439" y="1673352"/>
-            <a:ext cx="2377440" cy="1051560"/>
-          </a:xfrm>
-          <a:prstGeom prst="rect">
-            <a:avLst/>
-          </a:prstGeom>
-          <a:noFill/>
-        </p:spPr>
-        <p:txBody>
-          <a:bodyPr wrap="square">
-            <a:spAutoFit/>
-          </a:bodyPr>
-          <a:lstStyle/>
-          <a:p>
-            <a:pPr>
-              <a:spcAft>
-                <a:spcPts val="400"/>
-              </a:spcAft>
-            </a:pPr>
-            <a:r>
-              <a:rPr sz="1800" b="1" i="0">
-                <a:solidFill>
-                  <a:srgbClr val="00883A"/>
-                </a:solidFill>
-                <a:latin typeface="Arial"/>
-              </a:rPr>
-              <a:t>C2 </a:t>
-            </a:r>
-            <a:r>
-              <a:rPr sz="1700" b="0" i="0">
-                <a:solidFill>
-                  <a:srgbClr val="1A1A1A"/>
-                </a:solidFill>
-                <a:latin typeface="Arial"/>
-              </a:rPr>
-              <a:t>Portability</a:t>
-            </a:r>
-          </a:p>
-          <a:p>
-            <a:pPr>
-              <a:spcAft>
-                <a:spcPts val="400"/>
-              </a:spcAft>
-            </a:pPr>
-            <a:r>
-              <a:rPr sz="1800" b="1" i="0">
-                <a:solidFill>
-                  <a:srgbClr val="00883A"/>
-                </a:solidFill>
-                <a:latin typeface="Arial"/>
-              </a:rPr>
-              <a:t>■ </a:t>
-            </a:r>
-            <a:r>
-              <a:rPr sz="1800" b="1" i="0">
-                <a:solidFill>
-                  <a:srgbClr val="5F6368"/>
-                </a:solidFill>
-                <a:latin typeface="Arial"/>
-              </a:rPr>
-              <a:t>▲ </a:t>
-            </a:r>
-            <a:r>
-              <a:rPr sz="1800" b="1" i="0">
-                <a:solidFill>
-                  <a:srgbClr val="1A1A1A"/>
-                </a:solidFill>
-                <a:latin typeface="Arial"/>
-              </a:rPr>
-              <a:t>★ </a:t>
-            </a:r>
-          </a:p>
-        </p:txBody>
-      </p:sp>
-      <p:sp>
-        <p:nvSpPr>
-          <p:cNvPr id="139" name="Rounded Rectangle 138"/>
-          <p:cNvSpPr/>
-          <p:nvPr/>
-        </p:nvSpPr>
-        <p:spPr>
-          <a:xfrm>
-            <a:off x="6181344" y="1600200"/>
-            <a:ext cx="2587752" cy="1188720"/>
-          </a:xfrm>
-          <a:prstGeom prst="roundRect">
-            <a:avLst>
-              <a:gd name="adj" fmla="val 8000"/>
-            </a:avLst>
-          </a:prstGeom>
-          <a:solidFill>
-            <a:srgbClr val="F1F3F2"/>
-          </a:solidFill>
-          <a:ln>
-            <a:noFill/>
-          </a:ln>
-          <a:effectLst/>
-        </p:spPr>
-        <p:style>
-          <a:lnRef idx="1">
-            <a:schemeClr val="accent1"/>
-          </a:lnRef>
-          <a:fillRef idx="3">
-            <a:schemeClr val="accent1"/>
-          </a:fillRef>
-          <a:effectRef idx="2">
-            <a:schemeClr val="accent1"/>
-          </a:effectRef>
-          <a:fontRef idx="minor">
-            <a:schemeClr val="lt1"/>
-          </a:fontRef>
-        </p:style>
-        <p:txBody>
-          <a:bodyPr rtlCol="0" anchor="ctr"/>
-          <a:lstStyle/>
-          <a:p>
-            <a:pPr algn="ctr"/>
-          </a:p>
-        </p:txBody>
-      </p:sp>
-      <p:sp>
-        <p:nvSpPr>
-          <p:cNvPr id="140" name="TextBox 139"/>
-          <p:cNvSpPr txBox="1"/>
-          <p:nvPr/>
-        </p:nvSpPr>
-        <p:spPr>
-          <a:xfrm>
-            <a:off x="6291072" y="1673352"/>
-            <a:ext cx="2377440" cy="1051560"/>
-          </a:xfrm>
-          <a:prstGeom prst="rect">
-            <a:avLst/>
-          </a:prstGeom>
-          <a:noFill/>
-        </p:spPr>
-        <p:txBody>
-          <a:bodyPr wrap="square">
-            <a:spAutoFit/>
-          </a:bodyPr>
-          <a:lstStyle/>
-          <a:p>
-            <a:pPr>
-              <a:spcAft>
-                <a:spcPts val="400"/>
-              </a:spcAft>
-            </a:pPr>
-            <a:r>
-              <a:rPr sz="1800" b="1" i="0">
-                <a:solidFill>
-                  <a:srgbClr val="00883A"/>
-                </a:solidFill>
-                <a:latin typeface="Arial"/>
-              </a:rPr>
-              <a:t>C3 </a:t>
-            </a:r>
-            <a:r>
-              <a:rPr sz="1700" b="0" i="0">
-                <a:solidFill>
-                  <a:srgbClr val="1A1A1A"/>
-                </a:solidFill>
-                <a:latin typeface="Arial"/>
-              </a:rPr>
-              <a:t>Maintenance</a:t>
-            </a:r>
-          </a:p>
-          <a:p>
-            <a:pPr>
-              <a:spcAft>
-                <a:spcPts val="400"/>
-              </a:spcAft>
-            </a:pPr>
-            <a:r>
-              <a:rPr sz="1800" b="1" i="0">
-                <a:solidFill>
-                  <a:srgbClr val="00883A"/>
-                </a:solidFill>
-                <a:latin typeface="Arial"/>
-              </a:rPr>
-              <a:t>■ </a:t>
-            </a:r>
-            <a:r>
-              <a:rPr sz="1800" b="1" i="0">
-                <a:solidFill>
-                  <a:srgbClr val="5F6368"/>
-                </a:solidFill>
-                <a:latin typeface="Arial"/>
-              </a:rPr>
-              <a:t>▲ </a:t>
-            </a:r>
-          </a:p>
-        </p:txBody>
-      </p:sp>
-      <p:sp>
-        <p:nvSpPr>
-          <p:cNvPr id="141" name="Rounded Rectangle 140"/>
-          <p:cNvSpPr/>
-          <p:nvPr/>
-        </p:nvSpPr>
-        <p:spPr>
-          <a:xfrm>
-            <a:off x="8951976" y="1600200"/>
-            <a:ext cx="2587752" cy="1188720"/>
-          </a:xfrm>
-          <a:prstGeom prst="roundRect">
-            <a:avLst>
-              <a:gd name="adj" fmla="val 8000"/>
-            </a:avLst>
-          </a:prstGeom>
-          <a:solidFill>
-            <a:srgbClr val="F1F3F2"/>
-          </a:solidFill>
-          <a:ln>
-            <a:noFill/>
-          </a:ln>
-          <a:effectLst/>
-        </p:spPr>
-        <p:style>
-          <a:lnRef idx="1">
-            <a:schemeClr val="accent1"/>
-          </a:lnRef>
-          <a:fillRef idx="3">
-            <a:schemeClr val="accent1"/>
-          </a:fillRef>
-          <a:effectRef idx="2">
-            <a:schemeClr val="accent1"/>
-          </a:effectRef>
-          <a:fontRef idx="minor">
-            <a:schemeClr val="lt1"/>
-          </a:fontRef>
-        </p:style>
-        <p:txBody>
-          <a:bodyPr rtlCol="0" anchor="ctr"/>
-          <a:lstStyle/>
-          <a:p>
-            <a:pPr algn="ctr"/>
-          </a:p>
-        </p:txBody>
-      </p:sp>
-      <p:sp>
-        <p:nvSpPr>
-          <p:cNvPr id="142" name="TextBox 141"/>
-          <p:cNvSpPr txBox="1"/>
-          <p:nvPr/>
-        </p:nvSpPr>
-        <p:spPr>
-          <a:xfrm>
-            <a:off x="9061703" y="1673352"/>
-            <a:ext cx="2377440" cy="1051560"/>
-          </a:xfrm>
-          <a:prstGeom prst="rect">
-            <a:avLst/>
-          </a:prstGeom>
-          <a:noFill/>
-        </p:spPr>
-        <p:txBody>
-          <a:bodyPr wrap="square">
-            <a:spAutoFit/>
-          </a:bodyPr>
-          <a:lstStyle/>
-          <a:p>
-            <a:pPr>
-              <a:spcAft>
-                <a:spcPts val="400"/>
-              </a:spcAft>
-            </a:pPr>
-            <a:r>
-              <a:rPr sz="1800" b="1" i="0">
-                <a:solidFill>
-                  <a:srgbClr val="00883A"/>
-                </a:solidFill>
-                <a:latin typeface="Arial"/>
-              </a:rPr>
-              <a:t>C4 </a:t>
-            </a:r>
-            <a:r>
-              <a:rPr sz="1700" b="0" i="0">
-                <a:solidFill>
-                  <a:srgbClr val="1A1A1A"/>
-                </a:solidFill>
-                <a:latin typeface="Arial"/>
-              </a:rPr>
-              <a:t>Tacit knowledge</a:t>
-            </a:r>
-          </a:p>
-          <a:p>
-            <a:pPr>
-              <a:spcAft>
-                <a:spcPts val="400"/>
-              </a:spcAft>
-            </a:pPr>
-            <a:r>
-              <a:rPr sz="1800" b="1" i="0">
-                <a:solidFill>
-                  <a:srgbClr val="00883A"/>
-                </a:solidFill>
-                <a:latin typeface="Arial"/>
-              </a:rPr>
-              <a:t>■ </a:t>
-            </a:r>
-            <a:r>
-              <a:rPr sz="1800" b="1" i="0">
-                <a:solidFill>
-                  <a:srgbClr val="5F6368"/>
-                </a:solidFill>
-                <a:latin typeface="Arial"/>
-              </a:rPr>
-              <a:t>▲ </a:t>
-            </a:r>
-            <a:r>
-              <a:rPr sz="1800" b="1" i="0">
-                <a:solidFill>
-                  <a:srgbClr val="1A1A1A"/>
-                </a:solidFill>
-                <a:latin typeface="Arial"/>
-              </a:rPr>
-              <a:t>★ </a:t>
-            </a:r>
-          </a:p>
-        </p:txBody>
-      </p:sp>
-      <p:sp>
-        <p:nvSpPr>
-          <p:cNvPr id="143" name="Rounded Rectangle 142"/>
-          <p:cNvSpPr/>
-          <p:nvPr/>
-        </p:nvSpPr>
-        <p:spPr>
-          <a:xfrm>
-            <a:off x="640080" y="2971800"/>
-            <a:ext cx="2587752" cy="1188720"/>
-          </a:xfrm>
-          <a:prstGeom prst="roundRect">
-            <a:avLst>
-              <a:gd name="adj" fmla="val 8000"/>
-            </a:avLst>
-          </a:prstGeom>
-          <a:solidFill>
-            <a:srgbClr val="F1F3F2"/>
-          </a:solidFill>
-          <a:ln>
-            <a:noFill/>
-          </a:ln>
-          <a:effectLst/>
-        </p:spPr>
-        <p:style>
-          <a:lnRef idx="1">
-            <a:schemeClr val="accent1"/>
-          </a:lnRef>
-          <a:fillRef idx="3">
-            <a:schemeClr val="accent1"/>
-          </a:fillRef>
-          <a:effectRef idx="2">
-            <a:schemeClr val="accent1"/>
-          </a:effectRef>
-          <a:fontRef idx="minor">
-            <a:schemeClr val="lt1"/>
-          </a:fontRef>
-        </p:style>
-        <p:txBody>
-          <a:bodyPr rtlCol="0" anchor="ctr"/>
-          <a:lstStyle/>
-          <a:p>
-            <a:pPr algn="ctr"/>
-          </a:p>
-        </p:txBody>
-      </p:sp>
-      <p:sp>
-        <p:nvSpPr>
-          <p:cNvPr id="144" name="TextBox 143"/>
-          <p:cNvSpPr txBox="1"/>
-          <p:nvPr/>
-        </p:nvSpPr>
-        <p:spPr>
-          <a:xfrm>
-            <a:off x="749808" y="3044952"/>
-            <a:ext cx="2377440" cy="1051560"/>
-          </a:xfrm>
-          <a:prstGeom prst="rect">
-            <a:avLst/>
-          </a:prstGeom>
-          <a:noFill/>
-        </p:spPr>
-        <p:txBody>
-          <a:bodyPr wrap="square">
-            <a:spAutoFit/>
-          </a:bodyPr>
-          <a:lstStyle/>
-          <a:p>
-            <a:pPr>
-              <a:spcAft>
-                <a:spcPts val="400"/>
-              </a:spcAft>
-            </a:pPr>
-            <a:r>
-              <a:rPr sz="1800" b="1" i="0">
-                <a:solidFill>
-                  <a:srgbClr val="00883A"/>
-                </a:solidFill>
-                <a:latin typeface="Arial"/>
-              </a:rPr>
-              <a:t>C5 </a:t>
-            </a:r>
-            <a:r>
-              <a:rPr sz="1700" b="0" i="0">
-                <a:solidFill>
-                  <a:srgbClr val="1A1A1A"/>
-                </a:solidFill>
-                <a:latin typeface="Arial"/>
-              </a:rPr>
-              <a:t>Doesn’t fit purpose</a:t>
-            </a:r>
-          </a:p>
-          <a:p>
-            <a:pPr>
-              <a:spcAft>
-                <a:spcPts val="400"/>
-              </a:spcAft>
-            </a:pPr>
-            <a:r>
-              <a:rPr sz="1800" b="1" i="0">
-                <a:solidFill>
-                  <a:srgbClr val="5F6368"/>
-                </a:solidFill>
-                <a:latin typeface="Arial"/>
-              </a:rPr>
-              <a:t>▲ </a:t>
-            </a:r>
-          </a:p>
-        </p:txBody>
-      </p:sp>
-      <p:sp>
-        <p:nvSpPr>
-          <p:cNvPr id="145" name="Rounded Rectangle 144"/>
-          <p:cNvSpPr/>
-          <p:nvPr/>
-        </p:nvSpPr>
-        <p:spPr>
-          <a:xfrm>
-            <a:off x="3410711" y="2971800"/>
-            <a:ext cx="2587752" cy="1188720"/>
-          </a:xfrm>
-          <a:prstGeom prst="roundRect">
-            <a:avLst>
-              <a:gd name="adj" fmla="val 8000"/>
-            </a:avLst>
-          </a:prstGeom>
-          <a:solidFill>
-            <a:srgbClr val="F1F3F2"/>
-          </a:solidFill>
-          <a:ln>
-            <a:noFill/>
-          </a:ln>
-          <a:effectLst/>
-        </p:spPr>
-        <p:style>
-          <a:lnRef idx="1">
-            <a:schemeClr val="accent1"/>
-          </a:lnRef>
-          <a:fillRef idx="3">
-            <a:schemeClr val="accent1"/>
-          </a:fillRef>
-          <a:effectRef idx="2">
-            <a:schemeClr val="accent1"/>
-          </a:effectRef>
-          <a:fontRef idx="minor">
-            <a:schemeClr val="lt1"/>
-          </a:fontRef>
-        </p:style>
-        <p:txBody>
-          <a:bodyPr rtlCol="0" anchor="ctr"/>
-          <a:lstStyle/>
-          <a:p>
-            <a:pPr algn="ctr"/>
-          </a:p>
-        </p:txBody>
-      </p:sp>
-      <p:sp>
-        <p:nvSpPr>
-          <p:cNvPr id="146" name="TextBox 145"/>
-          <p:cNvSpPr txBox="1"/>
-          <p:nvPr/>
-        </p:nvSpPr>
-        <p:spPr>
-          <a:xfrm>
-            <a:off x="3520439" y="3044952"/>
-            <a:ext cx="2377440" cy="1051560"/>
-          </a:xfrm>
-          <a:prstGeom prst="rect">
-            <a:avLst/>
-          </a:prstGeom>
-          <a:noFill/>
-        </p:spPr>
-        <p:txBody>
-          <a:bodyPr wrap="square">
-            <a:spAutoFit/>
-          </a:bodyPr>
-          <a:lstStyle/>
-          <a:p>
-            <a:pPr>
-              <a:spcAft>
-                <a:spcPts val="400"/>
-              </a:spcAft>
-            </a:pPr>
-            <a:r>
-              <a:rPr sz="1800" b="1" i="0">
-                <a:solidFill>
-                  <a:srgbClr val="00883A"/>
-                </a:solidFill>
-                <a:latin typeface="Arial"/>
-              </a:rPr>
-              <a:t>C6 </a:t>
-            </a:r>
-            <a:r>
-              <a:rPr sz="1700" b="0" i="0">
-                <a:solidFill>
-                  <a:srgbClr val="1A1A1A"/>
-                </a:solidFill>
-                <a:latin typeface="Arial"/>
-              </a:rPr>
-              <a:t>No standards / guidelines</a:t>
-            </a:r>
-          </a:p>
-          <a:p>
-            <a:pPr>
-              <a:spcAft>
-                <a:spcPts val="400"/>
-              </a:spcAft>
-            </a:pPr>
-            <a:r>
-              <a:rPr sz="1800" b="1" i="0">
-                <a:solidFill>
-                  <a:srgbClr val="00883A"/>
-                </a:solidFill>
-                <a:latin typeface="Arial"/>
-              </a:rPr>
-              <a:t>■ </a:t>
-            </a:r>
-            <a:r>
-              <a:rPr sz="1800" b="1" i="0">
-                <a:solidFill>
-                  <a:srgbClr val="1A1A1A"/>
-                </a:solidFill>
-                <a:latin typeface="Arial"/>
-              </a:rPr>
-              <a:t>★ </a:t>
-            </a:r>
-          </a:p>
-        </p:txBody>
-      </p:sp>
-      <p:sp>
-        <p:nvSpPr>
-          <p:cNvPr id="147" name="Rounded Rectangle 146"/>
-          <p:cNvSpPr/>
-          <p:nvPr/>
-        </p:nvSpPr>
-        <p:spPr>
-          <a:xfrm>
-            <a:off x="6181344" y="2971800"/>
-            <a:ext cx="2587752" cy="1188720"/>
-          </a:xfrm>
-          <a:prstGeom prst="roundRect">
-            <a:avLst>
-              <a:gd name="adj" fmla="val 8000"/>
-            </a:avLst>
-          </a:prstGeom>
-          <a:solidFill>
-            <a:srgbClr val="F1F3F2"/>
-          </a:solidFill>
-          <a:ln>
-            <a:noFill/>
-          </a:ln>
-          <a:effectLst/>
-        </p:spPr>
-        <p:style>
-          <a:lnRef idx="1">
-            <a:schemeClr val="accent1"/>
-          </a:lnRef>
-          <a:fillRef idx="3">
-            <a:schemeClr val="accent1"/>
-          </a:fillRef>
-          <a:effectRef idx="2">
-            <a:schemeClr val="accent1"/>
-          </a:effectRef>
-          <a:fontRef idx="minor">
-            <a:schemeClr val="lt1"/>
-          </a:fontRef>
-        </p:style>
-        <p:txBody>
-          <a:bodyPr rtlCol="0" anchor="ctr"/>
-          <a:lstStyle/>
-          <a:p>
-            <a:pPr algn="ctr"/>
-          </a:p>
-        </p:txBody>
-      </p:sp>
-      <p:sp>
-        <p:nvSpPr>
-          <p:cNvPr id="148" name="TextBox 147"/>
-          <p:cNvSpPr txBox="1"/>
-          <p:nvPr/>
-        </p:nvSpPr>
-        <p:spPr>
-          <a:xfrm>
-            <a:off x="6291072" y="3044952"/>
-            <a:ext cx="2377440" cy="1051560"/>
-          </a:xfrm>
-          <a:prstGeom prst="rect">
-            <a:avLst/>
-          </a:prstGeom>
-          <a:noFill/>
-        </p:spPr>
-        <p:txBody>
-          <a:bodyPr wrap="square">
-            <a:spAutoFit/>
-          </a:bodyPr>
-          <a:lstStyle/>
-          <a:p>
-            <a:pPr>
-              <a:spcAft>
-                <a:spcPts val="400"/>
-              </a:spcAft>
-            </a:pPr>
-            <a:r>
-              <a:rPr sz="1800" b="1" i="0">
-                <a:solidFill>
-                  <a:srgbClr val="00883A"/>
-                </a:solidFill>
-                <a:latin typeface="Arial"/>
-              </a:rPr>
-              <a:t>C7 </a:t>
-            </a:r>
-            <a:r>
-              <a:rPr sz="1700" b="0" i="0">
-                <a:solidFill>
-                  <a:srgbClr val="1A1A1A"/>
-                </a:solidFill>
-                <a:latin typeface="Arial"/>
-              </a:rPr>
-              <a:t>Hosting</a:t>
-            </a:r>
-          </a:p>
-          <a:p>
-            <a:pPr>
-              <a:spcAft>
-                <a:spcPts val="400"/>
-              </a:spcAft>
-            </a:pPr>
-            <a:r>
-              <a:rPr sz="1800" b="1" i="0">
-                <a:solidFill>
-                  <a:srgbClr val="00883A"/>
-                </a:solidFill>
-                <a:latin typeface="Arial"/>
-              </a:rPr>
-              <a:t>■ </a:t>
-            </a:r>
-            <a:r>
-              <a:rPr sz="1800" b="1" i="0">
-                <a:solidFill>
-                  <a:srgbClr val="5F6368"/>
-                </a:solidFill>
-                <a:latin typeface="Arial"/>
-              </a:rPr>
-              <a:t>▲ </a:t>
-            </a:r>
-          </a:p>
-        </p:txBody>
-      </p:sp>
-      <p:sp>
-        <p:nvSpPr>
-          <p:cNvPr id="149" name="Rounded Rectangle 148"/>
-          <p:cNvSpPr/>
-          <p:nvPr/>
-        </p:nvSpPr>
-        <p:spPr>
-          <a:xfrm>
-            <a:off x="8951976" y="2971800"/>
-            <a:ext cx="2587752" cy="1188720"/>
-          </a:xfrm>
-          <a:prstGeom prst="roundRect">
-            <a:avLst>
-              <a:gd name="adj" fmla="val 8000"/>
-            </a:avLst>
-          </a:prstGeom>
-          <a:solidFill>
-            <a:srgbClr val="F1F3F2"/>
-          </a:solidFill>
-          <a:ln>
-            <a:noFill/>
-          </a:ln>
-          <a:effectLst/>
-        </p:spPr>
-        <p:style>
-          <a:lnRef idx="1">
-            <a:schemeClr val="accent1"/>
-          </a:lnRef>
-          <a:fillRef idx="3">
-            <a:schemeClr val="accent1"/>
-          </a:fillRef>
-          <a:effectRef idx="2">
-            <a:schemeClr val="accent1"/>
-          </a:effectRef>
-          <a:fontRef idx="minor">
-            <a:schemeClr val="lt1"/>
-          </a:fontRef>
-        </p:style>
-        <p:txBody>
-          <a:bodyPr rtlCol="0" anchor="ctr"/>
-          <a:lstStyle/>
-          <a:p>
-            <a:pPr algn="ctr"/>
-          </a:p>
-        </p:txBody>
-      </p:sp>
-      <p:sp>
-        <p:nvSpPr>
-          <p:cNvPr id="150" name="TextBox 149"/>
-          <p:cNvSpPr txBox="1"/>
-          <p:nvPr/>
-        </p:nvSpPr>
-        <p:spPr>
-          <a:xfrm>
-            <a:off x="9061703" y="3044952"/>
-            <a:ext cx="2377440" cy="1051560"/>
-          </a:xfrm>
-          <a:prstGeom prst="rect">
-            <a:avLst/>
-          </a:prstGeom>
-          <a:noFill/>
-        </p:spPr>
-        <p:txBody>
-          <a:bodyPr wrap="square">
-            <a:spAutoFit/>
-          </a:bodyPr>
-          <a:lstStyle/>
-          <a:p>
-            <a:pPr>
-              <a:spcAft>
-                <a:spcPts val="400"/>
-              </a:spcAft>
-            </a:pPr>
-            <a:r>
-              <a:rPr sz="1800" b="1" i="0">
-                <a:solidFill>
-                  <a:srgbClr val="00883A"/>
-                </a:solidFill>
-                <a:latin typeface="Arial"/>
-              </a:rPr>
-              <a:t>C8 </a:t>
-            </a:r>
-            <a:r>
-              <a:rPr sz="1700" b="0" i="0">
-                <a:solidFill>
-                  <a:srgbClr val="1A1A1A"/>
-                </a:solidFill>
-                <a:latin typeface="Arial"/>
-              </a:rPr>
-              <a:t>Double-blind review</a:t>
-            </a:r>
-          </a:p>
-          <a:p>
-            <a:pPr>
-              <a:spcAft>
-                <a:spcPts val="400"/>
-              </a:spcAft>
-            </a:pPr>
-            <a:r>
-              <a:rPr sz="1800" b="1" i="0">
-                <a:solidFill>
-                  <a:srgbClr val="00883A"/>
-                </a:solidFill>
-                <a:latin typeface="Arial"/>
-              </a:rPr>
-              <a:t>■ </a:t>
-            </a:r>
-          </a:p>
-        </p:txBody>
-      </p:sp>
-      <p:sp>
-        <p:nvSpPr>
-          <p:cNvPr id="151" name="Rounded Rectangle 150"/>
-          <p:cNvSpPr/>
-          <p:nvPr/>
-        </p:nvSpPr>
-        <p:spPr>
-          <a:xfrm>
-            <a:off x="640080" y="4343400"/>
-            <a:ext cx="2587752" cy="1188720"/>
-          </a:xfrm>
-          <a:prstGeom prst="roundRect">
-            <a:avLst>
-              <a:gd name="adj" fmla="val 8000"/>
-            </a:avLst>
-          </a:prstGeom>
-          <a:solidFill>
-            <a:srgbClr val="F1F3F2"/>
-          </a:solidFill>
-          <a:ln>
-            <a:noFill/>
-          </a:ln>
-          <a:effectLst/>
-        </p:spPr>
-        <p:style>
-          <a:lnRef idx="1">
-            <a:schemeClr val="accent1"/>
-          </a:lnRef>
-          <a:fillRef idx="3">
-            <a:schemeClr val="accent1"/>
-          </a:fillRef>
-          <a:effectRef idx="2">
-            <a:schemeClr val="accent1"/>
-          </a:effectRef>
-          <a:fontRef idx="minor">
-            <a:schemeClr val="lt1"/>
-          </a:fontRef>
-        </p:style>
-        <p:txBody>
-          <a:bodyPr rtlCol="0" anchor="ctr"/>
-          <a:lstStyle/>
-          <a:p>
-            <a:pPr algn="ctr"/>
-          </a:p>
-        </p:txBody>
-      </p:sp>
-      <p:sp>
-        <p:nvSpPr>
-          <p:cNvPr id="152" name="TextBox 151"/>
-          <p:cNvSpPr txBox="1"/>
-          <p:nvPr/>
-        </p:nvSpPr>
-        <p:spPr>
-          <a:xfrm>
-            <a:off x="749808" y="4416552"/>
-            <a:ext cx="2377440" cy="1051560"/>
-          </a:xfrm>
-          <a:prstGeom prst="rect">
-            <a:avLst/>
-          </a:prstGeom>
-          <a:noFill/>
-        </p:spPr>
-        <p:txBody>
-          <a:bodyPr wrap="square">
-            <a:spAutoFit/>
-          </a:bodyPr>
-          <a:lstStyle/>
-          <a:p>
-            <a:pPr>
-              <a:spcAft>
-                <a:spcPts val="400"/>
-              </a:spcAft>
-            </a:pPr>
-            <a:r>
-              <a:rPr sz="1800" b="1" i="0">
-                <a:solidFill>
-                  <a:srgbClr val="00883A"/>
-                </a:solidFill>
-                <a:latin typeface="Arial"/>
-              </a:rPr>
-              <a:t>C9 </a:t>
-            </a:r>
-            <a:r>
-              <a:rPr sz="1700" b="0" i="0">
-                <a:solidFill>
-                  <a:srgbClr val="1A1A1A"/>
-                </a:solidFill>
-                <a:latin typeface="Arial"/>
-              </a:rPr>
-              <a:t>External constraints</a:t>
-            </a:r>
-          </a:p>
-          <a:p>
-            <a:pPr>
-              <a:spcAft>
-                <a:spcPts val="400"/>
-              </a:spcAft>
-            </a:pPr>
-            <a:r>
-              <a:rPr sz="1800" b="1" i="0">
-                <a:solidFill>
-                  <a:srgbClr val="00883A"/>
-                </a:solidFill>
-                <a:latin typeface="Arial"/>
-              </a:rPr>
-              <a:t>■ </a:t>
-            </a:r>
-            <a:r>
-              <a:rPr sz="1800" b="1" i="0">
-                <a:solidFill>
-                  <a:srgbClr val="5F6368"/>
-                </a:solidFill>
-                <a:latin typeface="Arial"/>
-              </a:rPr>
-              <a:t>▲ </a:t>
-            </a:r>
-            <a:r>
-              <a:rPr sz="1800" b="1" i="0">
-                <a:solidFill>
-                  <a:srgbClr val="1A1A1A"/>
-                </a:solidFill>
-                <a:latin typeface="Arial"/>
-              </a:rPr>
-              <a:t>★ </a:t>
-            </a:r>
-          </a:p>
-        </p:txBody>
-      </p:sp>
-      <p:sp>
-        <p:nvSpPr>
-          <p:cNvPr id="153" name="Rounded Rectangle 152"/>
-          <p:cNvSpPr/>
-          <p:nvPr/>
-        </p:nvSpPr>
-        <p:spPr>
-          <a:xfrm>
-            <a:off x="3410711" y="4343400"/>
-            <a:ext cx="2587752" cy="1188720"/>
-          </a:xfrm>
-          <a:prstGeom prst="roundRect">
-            <a:avLst>
-              <a:gd name="adj" fmla="val 8000"/>
-            </a:avLst>
-          </a:prstGeom>
-          <a:solidFill>
-            <a:srgbClr val="F1F3F2"/>
-          </a:solidFill>
-          <a:ln>
-            <a:noFill/>
-          </a:ln>
-          <a:effectLst/>
-        </p:spPr>
-        <p:style>
-          <a:lnRef idx="1">
-            <a:schemeClr val="accent1"/>
-          </a:lnRef>
-          <a:fillRef idx="3">
-            <a:schemeClr val="accent1"/>
-          </a:fillRef>
-          <a:effectRef idx="2">
-            <a:schemeClr val="accent1"/>
-          </a:effectRef>
-          <a:fontRef idx="minor">
-            <a:schemeClr val="lt1"/>
-          </a:fontRef>
-        </p:style>
-        <p:txBody>
-          <a:bodyPr rtlCol="0" anchor="ctr"/>
-          <a:lstStyle/>
-          <a:p>
-            <a:pPr algn="ctr"/>
-          </a:p>
-        </p:txBody>
-      </p:sp>
-      <p:sp>
-        <p:nvSpPr>
-          <p:cNvPr id="154" name="TextBox 153"/>
-          <p:cNvSpPr txBox="1"/>
-          <p:nvPr/>
-        </p:nvSpPr>
-        <p:spPr>
-          <a:xfrm>
-            <a:off x="3520439" y="4416552"/>
-            <a:ext cx="2377440" cy="1051560"/>
-          </a:xfrm>
-          <a:prstGeom prst="rect">
-            <a:avLst/>
-          </a:prstGeom>
-          <a:noFill/>
-        </p:spPr>
-        <p:txBody>
-          <a:bodyPr wrap="square">
-            <a:spAutoFit/>
-          </a:bodyPr>
-          <a:lstStyle/>
-          <a:p>
-            <a:pPr>
-              <a:spcAft>
-                <a:spcPts val="400"/>
-              </a:spcAft>
-            </a:pPr>
-            <a:r>
-              <a:rPr sz="1800" b="1" i="0">
-                <a:solidFill>
-                  <a:srgbClr val="00883A"/>
-                </a:solidFill>
-                <a:latin typeface="Arial"/>
-              </a:rPr>
-              <a:t>C10 </a:t>
-            </a:r>
-            <a:r>
-              <a:rPr sz="1700" b="0" i="0">
-                <a:solidFill>
-                  <a:srgbClr val="1A1A1A"/>
-                </a:solidFill>
-                <a:latin typeface="Arial"/>
-              </a:rPr>
-              <a:t>No reviewer incentives</a:t>
-            </a:r>
-          </a:p>
-          <a:p>
-            <a:pPr>
-              <a:spcAft>
-                <a:spcPts val="400"/>
-              </a:spcAft>
-            </a:pPr>
-            <a:r>
-              <a:rPr sz="1800" b="1" i="0">
-                <a:solidFill>
-                  <a:srgbClr val="1A1A1A"/>
-                </a:solidFill>
-                <a:latin typeface="Arial"/>
-              </a:rPr>
-              <a:t>★ </a:t>
-            </a:r>
-          </a:p>
-        </p:txBody>
-      </p:sp>
-      <p:sp>
-        <p:nvSpPr>
-          <p:cNvPr id="155" name="Rounded Rectangle 154"/>
-          <p:cNvSpPr/>
-          <p:nvPr/>
-        </p:nvSpPr>
-        <p:spPr>
-          <a:xfrm>
-            <a:off x="6181344" y="4343400"/>
-            <a:ext cx="2587752" cy="1188720"/>
-          </a:xfrm>
-          <a:prstGeom prst="roundRect">
-            <a:avLst>
-              <a:gd name="adj" fmla="val 8000"/>
-            </a:avLst>
-          </a:prstGeom>
-          <a:solidFill>
-            <a:srgbClr val="F1F3F2"/>
-          </a:solidFill>
-          <a:ln>
-            <a:noFill/>
-          </a:ln>
-          <a:effectLst/>
-        </p:spPr>
-        <p:style>
-          <a:lnRef idx="1">
-            <a:schemeClr val="accent1"/>
-          </a:lnRef>
-          <a:fillRef idx="3">
-            <a:schemeClr val="accent1"/>
-          </a:fillRef>
-          <a:effectRef idx="2">
-            <a:schemeClr val="accent1"/>
-          </a:effectRef>
-          <a:fontRef idx="minor">
-            <a:schemeClr val="lt1"/>
-          </a:fontRef>
-        </p:style>
-        <p:txBody>
-          <a:bodyPr rtlCol="0" anchor="ctr"/>
-          <a:lstStyle/>
-          <a:p>
-            <a:pPr algn="ctr"/>
-          </a:p>
-        </p:txBody>
-      </p:sp>
-      <p:sp>
-        <p:nvSpPr>
-          <p:cNvPr id="156" name="TextBox 155"/>
-          <p:cNvSpPr txBox="1"/>
-          <p:nvPr/>
-        </p:nvSpPr>
-        <p:spPr>
-          <a:xfrm>
-            <a:off x="6291072" y="4416552"/>
-            <a:ext cx="2377440" cy="1051560"/>
-          </a:xfrm>
-          <a:prstGeom prst="rect">
-            <a:avLst/>
-          </a:prstGeom>
-          <a:noFill/>
-        </p:spPr>
-        <p:txBody>
-          <a:bodyPr wrap="square">
-            <a:spAutoFit/>
-          </a:bodyPr>
-          <a:lstStyle/>
-          <a:p>
-            <a:pPr>
-              <a:spcAft>
-                <a:spcPts val="400"/>
-              </a:spcAft>
-            </a:pPr>
-            <a:r>
-              <a:rPr sz="1800" b="1" i="0">
-                <a:solidFill>
-                  <a:srgbClr val="00883A"/>
-                </a:solidFill>
-                <a:latin typeface="Arial"/>
-              </a:rPr>
-              <a:t>C11 </a:t>
-            </a:r>
-            <a:r>
-              <a:rPr sz="1700" b="0" i="0">
-                <a:solidFill>
-                  <a:srgbClr val="1A1A1A"/>
-                </a:solidFill>
-                <a:latin typeface="Arial"/>
-              </a:rPr>
-              <a:t>Technical obstacles</a:t>
-            </a:r>
-          </a:p>
-          <a:p>
-            <a:pPr>
-              <a:spcAft>
-                <a:spcPts val="400"/>
-              </a:spcAft>
-            </a:pPr>
-            <a:r>
-              <a:rPr sz="1800" b="1" i="0">
-                <a:solidFill>
-                  <a:srgbClr val="1A1A1A"/>
-                </a:solidFill>
-                <a:latin typeface="Arial"/>
-              </a:rPr>
-              <a:t>★ </a:t>
-            </a:r>
-          </a:p>
-        </p:txBody>
-      </p:sp>
-      <p:sp>
-        <p:nvSpPr>
-          <p:cNvPr id="157" name="Rounded Rectangle 156"/>
-          <p:cNvSpPr/>
-          <p:nvPr/>
-        </p:nvSpPr>
-        <p:spPr>
-          <a:xfrm>
-            <a:off x="8951976" y="4343400"/>
-            <a:ext cx="2587752" cy="1188720"/>
-          </a:xfrm>
-          <a:prstGeom prst="roundRect">
-            <a:avLst>
-              <a:gd name="adj" fmla="val 8000"/>
-            </a:avLst>
-          </a:prstGeom>
-          <a:solidFill>
-            <a:srgbClr val="F1F3F2"/>
-          </a:solidFill>
-          <a:ln>
-            <a:noFill/>
-          </a:ln>
-          <a:effectLst/>
-        </p:spPr>
-        <p:style>
-          <a:lnRef idx="1">
-            <a:schemeClr val="accent1"/>
-          </a:lnRef>
-          <a:fillRef idx="3">
-            <a:schemeClr val="accent1"/>
-          </a:fillRef>
-          <a:effectRef idx="2">
-            <a:schemeClr val="accent1"/>
-          </a:effectRef>
-          <a:fontRef idx="minor">
-            <a:schemeClr val="lt1"/>
-          </a:fontRef>
-        </p:style>
-        <p:txBody>
-          <a:bodyPr rtlCol="0" anchor="ctr"/>
-          <a:lstStyle/>
-          <a:p>
-            <a:pPr algn="ctr"/>
-          </a:p>
-        </p:txBody>
-      </p:sp>
-      <p:sp>
-        <p:nvSpPr>
-          <p:cNvPr id="158" name="TextBox 157"/>
-          <p:cNvSpPr txBox="1"/>
-          <p:nvPr/>
-        </p:nvSpPr>
-        <p:spPr>
-          <a:xfrm>
-            <a:off x="9061703" y="4416552"/>
-            <a:ext cx="2377440" cy="1051560"/>
-          </a:xfrm>
-          <a:prstGeom prst="rect">
-            <a:avLst/>
-          </a:prstGeom>
-          <a:noFill/>
-        </p:spPr>
-        <p:txBody>
-          <a:bodyPr wrap="square">
-            <a:spAutoFit/>
-          </a:bodyPr>
-          <a:lstStyle/>
-          <a:p>
-            <a:pPr>
-              <a:spcAft>
-                <a:spcPts val="400"/>
-              </a:spcAft>
-            </a:pPr>
-            <a:r>
-              <a:rPr sz="1800" b="1" i="0">
-                <a:solidFill>
-                  <a:srgbClr val="00883A"/>
-                </a:solidFill>
-                <a:latin typeface="Arial"/>
-              </a:rPr>
-              <a:t>C12 </a:t>
-            </a:r>
-            <a:r>
-              <a:rPr sz="1700" b="0" i="0">
-                <a:solidFill>
-                  <a:srgbClr val="1A1A1A"/>
-                </a:solidFill>
-                <a:latin typeface="Arial"/>
-              </a:rPr>
-              <a:t>Limited communication</a:t>
-            </a:r>
-          </a:p>
-          <a:p>
-            <a:pPr>
-              <a:spcAft>
-                <a:spcPts val="400"/>
-              </a:spcAft>
-            </a:pPr>
-            <a:r>
-              <a:rPr sz="1800" b="1" i="0">
-                <a:solidFill>
-                  <a:srgbClr val="1A1A1A"/>
-                </a:solidFill>
-                <a:latin typeface="Arial"/>
-              </a:rPr>
-              <a:t>★ </a:t>
-            </a:r>
-          </a:p>
-        </p:txBody>
-      </p:sp>
-      <p:sp>
-        <p:nvSpPr>
-          <p:cNvPr id="159" name="TextBox 158"/>
-          <p:cNvSpPr txBox="1"/>
-          <p:nvPr/>
-        </p:nvSpPr>
-        <p:spPr>
-          <a:xfrm>
-            <a:off x="640080" y="5806440"/>
-            <a:ext cx="10908792" cy="457200"/>
-          </a:xfrm>
-          <a:prstGeom prst="rect">
-            <a:avLst/>
-          </a:prstGeom>
-          <a:noFill/>
-        </p:spPr>
-        <p:txBody>
-          <a:bodyPr wrap="square">
-            <a:spAutoFit/>
-          </a:bodyPr>
-          <a:lstStyle/>
-          <a:p>
-            <a:pPr>
-              <a:spcAft>
-                <a:spcPts val="600"/>
-              </a:spcAft>
-            </a:pPr>
-            <a:r>
-              <a:rPr sz="1600" b="1" i="0">
-                <a:solidFill>
-                  <a:srgbClr val="00883A"/>
-                </a:solidFill>
-                <a:latin typeface="Arial"/>
-              </a:rPr>
-              <a:t>■ </a:t>
-            </a:r>
-            <a:r>
-              <a:rPr sz="1600" b="0" i="0">
-                <a:solidFill>
-                  <a:srgbClr val="5F6368"/>
-                </a:solidFill>
-                <a:latin typeface="Arial"/>
-              </a:rPr>
-              <a:t>creator   </a:t>
-            </a:r>
-            <a:r>
-              <a:rPr sz="1600" b="1" i="0">
-                <a:solidFill>
-                  <a:srgbClr val="5F6368"/>
-                </a:solidFill>
-                <a:latin typeface="Arial"/>
-              </a:rPr>
-              <a:t>▲ </a:t>
-            </a:r>
-            <a:r>
-              <a:rPr sz="1600" b="0" i="0">
-                <a:solidFill>
-                  <a:srgbClr val="5F6368"/>
-                </a:solidFill>
-                <a:latin typeface="Arial"/>
-              </a:rPr>
-              <a:t>user   </a:t>
-            </a:r>
-            <a:r>
-              <a:rPr sz="1600" b="1" i="0">
-                <a:solidFill>
-                  <a:srgbClr val="1A1A1A"/>
-                </a:solidFill>
-                <a:latin typeface="Arial"/>
-              </a:rPr>
-              <a:t>★ </a:t>
-            </a:r>
-            <a:r>
-              <a:rPr sz="1600" b="0" i="0">
-                <a:solidFill>
-                  <a:srgbClr val="5F6368"/>
-                </a:solidFill>
-                <a:latin typeface="Arial"/>
-              </a:rPr>
-              <a:t>reviewer</a:t>
-            </a:r>
-          </a:p>
-        </p:txBody>
-      </p:sp>
-    </p:spTree>
-  </p:cSld>
-  <p:clrMapOvr>
-    <a:masterClrMapping/>
-  </p:clrMapOvr>
-</p:sld>
-</file>
-
-<file path=ppt/slides/slide71.xml><?xml version="1.0" encoding="utf-8"?>
 <p:sld xmlns:a="http://schemas.openxmlformats.org/drawingml/2006/main" xmlns:p="http://schemas.openxmlformats.org/presentationml/2006/main" xmlns:r="http://schemas.openxmlformats.org/officeDocument/2006/relationships">
   <p:cSld>
     <p:spTree>
@@ -47417,7 +46819,7 @@
                           </a:solidFill>
                           <a:latin typeface="Arial"/>
                         </a:rPr>
-                        <a:t>costly; time better spent on papers; little career benefit (p. 13)</a:t>
+                        <a:t>costly; time better spent on papers; little career benefit</a:t>
                       </a:r>
                     </a:p>
                     <a:p>
@@ -47492,7 +46894,7 @@
                           </a:solidFill>
                           <a:latin typeface="Arial"/>
                         </a:rPr>
-                        <a:t>counterpoint: whole research areas died for lack of artifacts (p. 15)</a:t>
+                        <a:t>counterpoint: whole research areas died for lack of artifacts</a:t>
                       </a:r>
                     </a:p>
                   </a:txBody>
@@ -47590,7 +46992,7 @@
                           </a:solidFill>
                           <a:latin typeface="Arial"/>
                         </a:rPr>
-                        <a:t>hard to anticipate environments; retrofit = refactor or VM/container, test elsewhere (p. 15)</a:t>
+                        <a:t>hard to anticipate environments; retrofit = refactor or VM/container, test elsewhere</a:t>
                       </a:r>
                     </a:p>
                     <a:p>
@@ -47615,7 +47017,7 @@
                           </a:solidFill>
                           <a:latin typeface="Arial"/>
                         </a:rPr>
-                        <a:t>hard-wired paths, root needed; build and run failures (p. 18)</a:t>
+                        <a:t>hard-wired paths, root needed; build and run failures</a:t>
                       </a:r>
                     </a:p>
                     <a:p>
@@ -47640,7 +47042,7 @@
                           </a:solidFill>
                           <a:latin typeface="Arial"/>
                         </a:rPr>
-                        <a:t>installing dependencies = main review hurdle; invasive libraries (p. 21)</a:t>
+                        <a:t>installing dependencies = main review hurdle; invasive libraries</a:t>
                       </a:r>
                     </a:p>
                     <a:p>
@@ -47665,7 +47067,7 @@
                           </a:solidFill>
                           <a:latin typeface="Arial"/>
                         </a:rPr>
-                        <a:t>VMs: safe but huge, cross-OS issues, no performance check; containers don’t stop decay (p. 22)</a:t>
+                        <a:t>VMs: safe but huge, cross-OS issues, no performance check; containers don’t stop decay</a:t>
                       </a:r>
                     </a:p>
                   </a:txBody>
@@ -47754,7 +47156,7 @@
                           </a:solidFill>
                           <a:latin typeface="Arial"/>
                         </a:rPr>
-                        <a:t>ongoing cost: bugs, changing use cases, bitrot (p. 16)</a:t>
+                        <a:t>ongoing cost: bugs, changing use cases, bitrot</a:t>
                       </a:r>
                     </a:p>
                     <a:p>
@@ -47804,7 +47206,7 @@
                           </a:solidFill>
                           <a:latin typeface="Arial"/>
                         </a:rPr>
-                        <a:t>unmaintained artifacts need old libraries that are ever harder to get (p. 19)</a:t>
+                        <a:t>unmaintained artifacts need old libraries that are ever harder to get</a:t>
                       </a:r>
                     </a:p>
                   </a:txBody>
@@ -47827,7 +47229,7 @@
 </p:sld>
 </file>
 
-<file path=ppt/slides/slide72.xml><?xml version="1.0" encoding="utf-8"?>
+<file path=ppt/slides/slide71.xml><?xml version="1.0" encoding="utf-8"?>
 <p:sld xmlns:a="http://schemas.openxmlformats.org/drawingml/2006/main" xmlns:p="http://schemas.openxmlformats.org/presentationml/2006/main" xmlns:r="http://schemas.openxmlformats.org/officeDocument/2006/relationships">
   <p:cSld>
     <p:spTree>
@@ -48238,7 +47640,7 @@
                           </a:solidFill>
                           <a:latin typeface="Arial"/>
                         </a:rPr>
-                        <a:t>documentation and refactoring burdensome; know-how "in developers’ heads"; prototypes change fast (p. 16)</a:t>
+                        <a:t>documentation and refactoring burdensome; know-how "in developers’ heads"; prototypes change fast</a:t>
                       </a:r>
                     </a:p>
                     <a:p>
@@ -48263,7 +47665,7 @@
                           </a:solidFill>
                           <a:latin typeface="Arial"/>
                         </a:rPr>
-                        <a:t>missing usage and build instructions = most common user problems (Table 5)</a:t>
+                        <a:t>missing usage and build instructions = most common user problems</a:t>
                       </a:r>
                     </a:p>
                     <a:p>
@@ -48288,7 +47690,7 @@
                           </a:solidFill>
                           <a:latin typeface="Arial"/>
                         </a:rPr>
-                        <a:t>instructions incomplete, had to read the paper to fill gaps (p. 22)</a:t>
+                        <a:t>instructions incomplete, had to read the paper to fill gaps</a:t>
                       </a:r>
                     </a:p>
                     <a:p>
@@ -48313,7 +47715,7 @@
                           </a:solidFill>
                           <a:latin typeface="Arial"/>
                         </a:rPr>
-                        <a:t>scripts no panacea: black box, may repeat authors’ mistakes; docs still needed (p. 22)</a:t>
+                        <a:t>scripts no panacea: black box, may repeat authors’ mistakes; docs still needed</a:t>
                       </a:r>
                     </a:p>
                   </a:txBody>
@@ -48393,7 +47795,7 @@
                           </a:solidFill>
                           <a:latin typeface="Arial"/>
                         </a:rPr>
-                        <a:t>doesn’t serve the purpose stated in the paper; very narrow use cases (p. 19)</a:t>
+                        <a:t>doesn’t serve the purpose stated in the paper; very narrow use cases</a:t>
                       </a:r>
                     </a:p>
                     <a:p>
@@ -48507,7 +47909,7 @@
                           </a:solidFill>
                           <a:latin typeface="Arial"/>
                         </a:rPr>
-                        <a:t>unclear packaging, contents, quality; how to handle existing datasets (p. 16)</a:t>
+                        <a:t>unclear packaging, contents, quality; how to handle existing datasets</a:t>
                       </a:r>
                     </a:p>
                     <a:p>
@@ -48557,7 +47959,7 @@
                           </a:solidFill>
                           <a:latin typeface="Arial"/>
                         </a:rPr>
-                        <a:t>review criteria and ACM badge text vague, "too general" (p. 22)</a:t>
+                        <a:t>review criteria and ACM badge text vague, "too general"</a:t>
                       </a:r>
                     </a:p>
                     <a:p>
@@ -48582,7 +47984,7 @@
                           </a:solidFill>
                           <a:latin typeface="Arial"/>
                         </a:rPr>
-                        <a:t>unclear purpose (run scripts vs. deep dive) and link to paper acceptance: reject or "rubber stamp"? (pp. 22-23)</a:t>
+                        <a:t>unclear purpose (run scripts vs. deep dive) and link to paper acceptance: reject or "rubber stamp"?</a:t>
                       </a:r>
                     </a:p>
                   </a:txBody>
@@ -48605,7 +48007,7 @@
 </p:sld>
 </file>
 
-<file path=ppt/slides/slide73.xml><?xml version="1.0" encoding="utf-8"?>
+<file path=ppt/slides/slide72.xml><?xml version="1.0" encoding="utf-8"?>
 <p:sld xmlns:a="http://schemas.openxmlformats.org/drawingml/2006/main" xmlns:p="http://schemas.openxmlformats.org/presentationml/2006/main" xmlns:r="http://schemas.openxmlformats.org/officeDocument/2006/relationships">
   <p:cSld>
     <p:spTree>
@@ -49007,7 +48409,7 @@
                           </a:solidFill>
                           <a:latin typeface="Arial"/>
                         </a:rPr>
-                        <a:t>needs indefinite, large, free hosting; GitHub, Drive, Dropbox aren’t archives (p. 17)</a:t>
+                        <a:t>needs indefinite, large, free hosting; GitHub, Drive, Dropbox aren’t archives</a:t>
                       </a:r>
                     </a:p>
                     <a:p>
@@ -49032,7 +48434,7 @@
                           </a:solidFill>
                           <a:latin typeface="Arial"/>
                         </a:rPr>
-                        <a:t>inaccessible artifacts = 2nd most common user problem; dead links rise with age (Fig. 3, p. 20)</a:t>
+                        <a:t>inaccessible artifacts = 2nd most common user problem; dead links rise with age</a:t>
                       </a:r>
                     </a:p>
                   </a:txBody>
@@ -49112,7 +48514,7 @@
                           </a:solidFill>
                           <a:latin typeface="Arial"/>
                         </a:rPr>
-                        <a:t>artifact must be anonymised; anonymous hosting hard to find (p. 17)</a:t>
+                        <a:t>artifact must be anonymised; anonymous hosting hard to find</a:t>
                       </a:r>
                     </a:p>
                   </a:txBody>
@@ -49210,7 +48612,7 @@
                           </a:solidFill>
                           <a:latin typeface="Arial"/>
                         </a:rPr>
-                        <a:t>IP and contracts, liability fears, privacy (re-identifiable qualitative data), larger ecosystems (pp. 17-18)</a:t>
+                        <a:t>IP and contracts, liability fears, privacy (re-identifiable qualitative data), larger ecosystems</a:t>
                       </a:r>
                     </a:p>
                     <a:p>
@@ -49260,7 +48662,7 @@
                           </a:solidFill>
                           <a:latin typeface="Arial"/>
                         </a:rPr>
-                        <a:t>licences block extension; decompiling; paid licences for tools (p. 20)</a:t>
+                        <a:t>licences block extension; decompiling; paid licences for tools</a:t>
                       </a:r>
                     </a:p>
                     <a:p>
@@ -49285,7 +48687,7 @@
                           </a:solidFill>
                           <a:latin typeface="Arial"/>
                         </a:rPr>
-                        <a:t>reviewers lack licences; no pathway for proprietary components (p. 23)</a:t>
+                        <a:t>reviewers lack licences; no pathway for proprietary components</a:t>
                       </a:r>
                     </a:p>
                   </a:txBody>
@@ -49308,7 +48710,7 @@
 </p:sld>
 </file>
 
-<file path=ppt/slides/slide74.xml><?xml version="1.0" encoding="utf-8"?>
+<file path=ppt/slides/slide73.xml><?xml version="1.0" encoding="utf-8"?>
 <p:sld xmlns:a="http://schemas.openxmlformats.org/drawingml/2006/main" xmlns:p="http://schemas.openxmlformats.org/presentationml/2006/main" xmlns:r="http://schemas.openxmlformats.org/officeDocument/2006/relationships">
   <p:cSld>
     <p:spTree>
@@ -49701,7 +49103,7 @@
                           </a:solidFill>
                           <a:latin typeface="Arial"/>
                         </a:rPr>
-                        <a:t>time-consuming, not rewarded like paper review (p. 23)</a:t>
+                        <a:t>time-consuming, not rewarded like paper review</a:t>
                       </a:r>
                     </a:p>
                     <a:p>
@@ -49831,7 +49233,7 @@
                           </a:solidFill>
                           <a:latin typeface="Arial"/>
                         </a:rPr>
-                        <a:t>long runtimes, little compute; what if &gt; 1 day per artifact? (p. 23)</a:t>
+                        <a:t>long runtimes, little compute; what if &gt; 1 day per artifact?</a:t>
                       </a:r>
                     </a:p>
                     <a:p>
@@ -49881,7 +49283,7 @@
                           </a:solidFill>
                           <a:latin typeface="Arial"/>
                         </a:rPr>
-                        <a:t>some experiments infeasible to re-run: cloud, fuzzing, program repair (pp. 23-24)</a:t>
+                        <a:t>some experiments infeasible to re-run: cloud, fuzzing, program repair</a:t>
                       </a:r>
                     </a:p>
                   </a:txBody>
@@ -49961,7 +49363,7 @@
                           </a:solidFill>
                           <a:latin typeface="Arial"/>
                         </a:rPr>
-                        <a:t>single-round reviews: minor install glitch shouldn’t mean rejection (p. 24)</a:t>
+                        <a:t>single-round reviews: minor install glitch shouldn’t mean rejection</a:t>
                       </a:r>
                     </a:p>
                     <a:p>
@@ -50035,7 +49437,246 @@
                 </a:solidFill>
                 <a:latin typeface="Arial"/>
               </a:rPr>
-              <a:t>Context (Fig. 4, p. 21): few artifact papers are submitted to AE (FSE 2015-18: 74 of 196), and most of those pass (86 %); some reviewers are happy with the process.</a:t>
+              <a:t>Context: few artifact papers are submitted to AE (FSE 2015-18: 74 of 196), and most of those pass (86 %); some reviewers are happy with the process.</a:t>
+            </a:r>
+          </a:p>
+        </p:txBody>
+      </p:sp>
+    </p:spTree>
+  </p:cSld>
+  <p:clrMapOvr>
+    <a:masterClrMapping/>
+  </p:clrMapOvr>
+</p:sld>
+</file>
+
+<file path=ppt/slides/slide74.xml><?xml version="1.0" encoding="utf-8"?>
+<p:sld xmlns:a="http://schemas.openxmlformats.org/drawingml/2006/main" xmlns:p="http://schemas.openxmlformats.org/presentationml/2006/main" xmlns:r="http://schemas.openxmlformats.org/officeDocument/2006/relationships">
+  <p:cSld>
+    <p:spTree>
+      <p:nvGrpSpPr>
+        <p:cNvPr id="1" name=""/>
+        <p:cNvGrpSpPr/>
+        <p:nvPr/>
+      </p:nvGrpSpPr>
+      <p:grpSpPr/>
+      <p:sp>
+        <p:nvSpPr>
+          <p:cNvPr id="131" name="Google Shape;131;p16"/>
+          <p:cNvSpPr txBox="1"/>
+          <p:nvPr/>
+        </p:nvSpPr>
+        <p:spPr>
+          <a:xfrm>
+            <a:off x="640080" y="365760"/>
+            <a:ext cx="10911600" cy="822900"/>
+          </a:xfrm>
+          <a:prstGeom prst="rect">
+            <a:avLst/>
+          </a:prstGeom>
+          <a:noFill/>
+          <a:ln>
+            <a:noFill/>
+          </a:ln>
+        </p:spPr>
+        <p:txBody>
+          <a:bodyPr anchorCtr="0" anchor="ctr" bIns="0" lIns="0" spcFirstLastPara="1" rIns="0" wrap="square" tIns="0">
+            <a:noAutofit/>
+          </a:bodyPr>
+          <a:lstStyle/>
+          <a:p>
+            <a:pPr indent="0" lvl="0" marL="0" marR="0" rtl="0" algn="l">
+              <a:spcBef>
+                <a:spcPts val="0"/>
+              </a:spcBef>
+              <a:spcAft>
+                <a:spcPts val="0"/>
+              </a:spcAft>
+              <a:buClr>
+                <a:srgbClr val="00883A"/>
+              </a:buClr>
+              <a:buSzPts val="4000"/>
+              <a:buFont typeface="Arial"/>
+              <a:buNone/>
+            </a:pPr>
+            <a:r>
+              <a:rPr b="1" i="0" lang="en-US" sz="4000" u="none" cap="none" strike="noStrike">
+                <a:solidFill>
+                  <a:srgbClr val="00883A"/>
+                </a:solidFill>
+                <a:latin typeface="Arial"/>
+                <a:ea typeface="Arial"/>
+                <a:cs typeface="Arial"/>
+                <a:sym typeface="Arial"/>
+              </a:rPr>
+              <a:t>References</a:t>
+            </a:r>
+            <a:endParaRPr b="0" i="0" sz="4000" u="none" cap="none" strike="noStrike">
+              <a:solidFill>
+                <a:schemeClr val="dk1"/>
+              </a:solidFill>
+              <a:latin typeface="Arial"/>
+              <a:ea typeface="Arial"/>
+              <a:cs typeface="Arial"/>
+              <a:sym typeface="Arial"/>
+            </a:endParaRPr>
+          </a:p>
+        </p:txBody>
+      </p:sp>
+      <p:sp>
+        <p:nvSpPr>
+          <p:cNvPr id="133" name="Google Shape;133;p16"/>
+          <p:cNvSpPr txBox="1"/>
+          <p:nvPr>
+            <p:ph idx="4294967295" type="sldNum"/>
+          </p:nvPr>
+        </p:nvSpPr>
+        <p:spPr>
+          <a:xfrm>
+            <a:off x="11247120" y="6355080"/>
+            <a:ext cx="548700" cy="320100"/>
+          </a:xfrm>
+          <a:prstGeom prst="rect">
+            <a:avLst/>
+          </a:prstGeom>
+          <a:noFill/>
+          <a:ln>
+            <a:noFill/>
+          </a:ln>
+        </p:spPr>
+        <p:txBody>
+          <a:bodyPr anchorCtr="0" anchor="t" bIns="45700" lIns="91425" spcFirstLastPara="1" rIns="91425" wrap="square" tIns="45700">
+            <a:noAutofit/>
+          </a:bodyPr>
+          <a:lstStyle/>
+          <a:p>
+            <a:pPr indent="0" lvl="0" marL="0" marR="0" rtl="0" algn="l">
+              <a:spcBef>
+                <a:spcPts val="0"/>
+              </a:spcBef>
+              <a:spcAft>
+                <a:spcPts val="0"/>
+              </a:spcAft>
+              <a:buNone/>
+            </a:pPr>
+            <a:fld id="{00000000-1234-1234-1234-123412341234}" type="slidenum">
+              <a:rPr b="0" i="0" lang="en-US" sz="1100" u="none" cap="none" strike="noStrike">
+                <a:solidFill>
+                  <a:srgbClr val="5F6368"/>
+                </a:solidFill>
+                <a:latin typeface="Arial"/>
+                <a:ea typeface="Arial"/>
+                <a:cs typeface="Arial"/>
+                <a:sym typeface="Arial"/>
+              </a:rPr>
+              <a:t>‹#›</a:t>
+            </a:fld>
+            <a:endParaRPr b="0" i="0" sz="1100" u="none" cap="none" strike="noStrike">
+              <a:solidFill>
+                <a:srgbClr val="5F6368"/>
+              </a:solidFill>
+              <a:latin typeface="Arial"/>
+              <a:ea typeface="Arial"/>
+              <a:cs typeface="Arial"/>
+              <a:sym typeface="Arial"/>
+            </a:endParaRPr>
+          </a:p>
+        </p:txBody>
+      </p:sp>
+      <p:sp>
+        <p:nvSpPr>
+          <p:cNvPr id="134" name="TextBox 133"/>
+          <p:cNvSpPr txBox="1"/>
+          <p:nvPr/>
+        </p:nvSpPr>
+        <p:spPr>
+          <a:xfrm>
+            <a:off x="640080" y="1463040"/>
+            <a:ext cx="10908792" cy="4114800"/>
+          </a:xfrm>
+          <a:prstGeom prst="rect">
+            <a:avLst/>
+          </a:prstGeom>
+          <a:noFill/>
+        </p:spPr>
+        <p:txBody>
+          <a:bodyPr wrap="square">
+            <a:spAutoFit/>
+          </a:bodyPr>
+          <a:lstStyle/>
+          <a:p>
+            <a:pPr>
+              <a:spcAft>
+                <a:spcPts val="1400"/>
+              </a:spcAft>
+            </a:pPr>
+            <a:r>
+              <a:rPr sz="1800" b="1" i="0">
+                <a:solidFill>
+                  <a:srgbClr val="1A1A1A"/>
+                </a:solidFill>
+                <a:latin typeface="Arial"/>
+              </a:rPr>
+              <a:t>[1] </a:t>
+            </a:r>
+            <a:r>
+              <a:rPr sz="1800" b="0" i="0">
+                <a:solidFill>
+                  <a:srgbClr val="1A1A1A"/>
+                </a:solidFill>
+                <a:latin typeface="Arial"/>
+              </a:rPr>
+              <a:t>ACM: Artifact Review and Badging, Version 1.1 (2020). acm.org/publications/policies/artifact-review-and-badging-current</a:t>
+            </a:r>
+          </a:p>
+          <a:p>
+            <a:pPr>
+              <a:spcAft>
+                <a:spcPts val="1400"/>
+              </a:spcAft>
+            </a:pPr>
+            <a:r>
+              <a:rPr sz="1800" b="1" i="0">
+                <a:solidFill>
+                  <a:srgbClr val="1A1A1A"/>
+                </a:solidFill>
+                <a:latin typeface="Arial"/>
+              </a:rPr>
+              <a:t>[2] </a:t>
+            </a:r>
+            <a:r>
+              <a:rPr sz="1800" b="0" i="0">
+                <a:solidFill>
+                  <a:srgbClr val="1A1A1A"/>
+                </a:solidFill>
+                <a:latin typeface="Arial"/>
+              </a:rPr>
+              <a:t>Winter &amp; Beyer: Introductory Lecture, Reproducibility of Scientific Results in SE Research, LMU (slide 9)</a:t>
+            </a:r>
+          </a:p>
+          <a:p>
+            <a:pPr>
+              <a:spcAft>
+                <a:spcPts val="1400"/>
+              </a:spcAft>
+            </a:pPr>
+            <a:r>
+              <a:rPr sz="1800" b="1" i="0">
+                <a:solidFill>
+                  <a:srgbClr val="1A1A1A"/>
+                </a:solidFill>
+                <a:latin typeface="Arial"/>
+              </a:rPr>
+              <a:t>[3] </a:t>
+            </a:r>
+            <a:r>
+              <a:rPr sz="1800" b="0" i="0">
+                <a:solidFill>
+                  <a:srgbClr val="1A1A1A"/>
+                </a:solidFill>
+                <a:latin typeface="Arial"/>
+              </a:rPr>
+              <a:t>ICSE 2026 Artifact Evaluation track, call for submissions. conf.researchr.org/track/icse-2026/icse-2026-artifact-evaluation</a:t>
             </a:r>
           </a:p>
         </p:txBody>

</xml_diff>